<commit_message>
Lesson 3 Slides Final
</commit_message>
<xml_diff>
--- a/Python/Lesson 03 - Functions/Lesson 03 - Functions.pptx
+++ b/Python/Lesson 03 - Functions/Lesson 03 - Functions.pptx
@@ -5,47 +5,48 @@
     <p:sldMasterId id="2147483684" r:id="rId1"/>
   </p:sldMasterIdLst>
   <p:notesMasterIdLst>
-    <p:notesMasterId r:id="rId30"/>
+    <p:notesMasterId r:id="rId31"/>
   </p:notesMasterIdLst>
   <p:sldIdLst>
     <p:sldId id="256" r:id="rId2"/>
-    <p:sldId id="488" r:id="rId3"/>
-    <p:sldId id="489" r:id="rId4"/>
-    <p:sldId id="486" r:id="rId5"/>
-    <p:sldId id="491" r:id="rId6"/>
-    <p:sldId id="257" r:id="rId7"/>
-    <p:sldId id="490" r:id="rId8"/>
-    <p:sldId id="492" r:id="rId9"/>
-    <p:sldId id="419" r:id="rId10"/>
-    <p:sldId id="493" r:id="rId11"/>
-    <p:sldId id="500" r:id="rId12"/>
-    <p:sldId id="494" r:id="rId13"/>
-    <p:sldId id="405" r:id="rId14"/>
-    <p:sldId id="495" r:id="rId15"/>
-    <p:sldId id="496" r:id="rId16"/>
-    <p:sldId id="424" r:id="rId17"/>
-    <p:sldId id="498" r:id="rId18"/>
-    <p:sldId id="499" r:id="rId19"/>
-    <p:sldId id="433" r:id="rId20"/>
-    <p:sldId id="501" r:id="rId21"/>
-    <p:sldId id="477" r:id="rId22"/>
-    <p:sldId id="462" r:id="rId23"/>
-    <p:sldId id="465" r:id="rId24"/>
-    <p:sldId id="484" r:id="rId25"/>
-    <p:sldId id="481" r:id="rId26"/>
-    <p:sldId id="482" r:id="rId27"/>
-    <p:sldId id="282" r:id="rId28"/>
-    <p:sldId id="476" r:id="rId29"/>
+    <p:sldId id="502" r:id="rId3"/>
+    <p:sldId id="488" r:id="rId4"/>
+    <p:sldId id="489" r:id="rId5"/>
+    <p:sldId id="486" r:id="rId6"/>
+    <p:sldId id="491" r:id="rId7"/>
+    <p:sldId id="257" r:id="rId8"/>
+    <p:sldId id="490" r:id="rId9"/>
+    <p:sldId id="492" r:id="rId10"/>
+    <p:sldId id="419" r:id="rId11"/>
+    <p:sldId id="493" r:id="rId12"/>
+    <p:sldId id="500" r:id="rId13"/>
+    <p:sldId id="494" r:id="rId14"/>
+    <p:sldId id="405" r:id="rId15"/>
+    <p:sldId id="495" r:id="rId16"/>
+    <p:sldId id="496" r:id="rId17"/>
+    <p:sldId id="424" r:id="rId18"/>
+    <p:sldId id="498" r:id="rId19"/>
+    <p:sldId id="499" r:id="rId20"/>
+    <p:sldId id="433" r:id="rId21"/>
+    <p:sldId id="501" r:id="rId22"/>
+    <p:sldId id="477" r:id="rId23"/>
+    <p:sldId id="462" r:id="rId24"/>
+    <p:sldId id="465" r:id="rId25"/>
+    <p:sldId id="484" r:id="rId26"/>
+    <p:sldId id="481" r:id="rId27"/>
+    <p:sldId id="482" r:id="rId28"/>
+    <p:sldId id="282" r:id="rId29"/>
+    <p:sldId id="476" r:id="rId30"/>
   </p:sldIdLst>
   <p:sldSz cx="9144000" cy="5143500" type="screen16x9"/>
   <p:notesSz cx="6858000" cy="9144000"/>
   <p:embeddedFontLst>
     <p:embeddedFont>
       <p:font typeface="Roboto" panose="02000000000000000000" pitchFamily="2" charset="0"/>
-      <p:regular r:id="rId31"/>
-      <p:bold r:id="rId32"/>
-      <p:italic r:id="rId33"/>
-      <p:boldItalic r:id="rId34"/>
+      <p:regular r:id="rId32"/>
+      <p:bold r:id="rId33"/>
+      <p:italic r:id="rId34"/>
+      <p:boldItalic r:id="rId35"/>
     </p:embeddedFont>
   </p:embeddedFontLst>
   <p:defaultTextStyle>
@@ -1002,6 +1003,103 @@
   <p:cSld>
     <p:spTree>
       <p:nvGrpSpPr>
+        <p:cNvPr id="1" name=""/>
+        <p:cNvGrpSpPr/>
+        <p:nvPr/>
+      </p:nvGrpSpPr>
+      <p:grpSpPr>
+        <a:xfrm>
+          <a:off x="0" y="0"/>
+          <a:ext cx="0" cy="0"/>
+          <a:chOff x="0" y="0"/>
+          <a:chExt cx="0" cy="0"/>
+        </a:xfrm>
+      </p:grpSpPr>
+      <p:sp>
+        <p:nvSpPr>
+          <p:cNvPr id="2" name="Slide Image Placeholder 1"/>
+          <p:cNvSpPr>
+            <a:spLocks noGrp="1" noRot="1" noChangeAspect="1"/>
+          </p:cNvSpPr>
+          <p:nvPr>
+            <p:ph type="sldImg"/>
+          </p:nvPr>
+        </p:nvSpPr>
+        <p:spPr>
+          <a:xfrm>
+            <a:off x="381000" y="685800"/>
+            <a:ext cx="6096000" cy="3429000"/>
+          </a:xfrm>
+        </p:spPr>
+      </p:sp>
+      <p:sp>
+        <p:nvSpPr>
+          <p:cNvPr id="3" name="Notes Placeholder 2"/>
+          <p:cNvSpPr>
+            <a:spLocks noGrp="1"/>
+          </p:cNvSpPr>
+          <p:nvPr>
+            <p:ph type="body" idx="1"/>
+          </p:nvPr>
+        </p:nvSpPr>
+        <p:spPr/>
+        <p:txBody>
+          <a:bodyPr>
+            <a:normAutofit/>
+          </a:bodyPr>
+          <a:lstStyle/>
+          <a:p>
+            <a:endParaRPr lang="en-US" dirty="0"/>
+          </a:p>
+        </p:txBody>
+      </p:sp>
+      <p:sp>
+        <p:nvSpPr>
+          <p:cNvPr id="4" name="Slide Number Placeholder 3"/>
+          <p:cNvSpPr>
+            <a:spLocks noGrp="1"/>
+          </p:cNvSpPr>
+          <p:nvPr>
+            <p:ph type="sldNum" sz="quarter" idx="5"/>
+          </p:nvPr>
+        </p:nvSpPr>
+        <p:spPr/>
+        <p:txBody>
+          <a:bodyPr/>
+          <a:lstStyle/>
+          <a:p>
+            <a:pPr>
+              <a:defRPr/>
+            </a:pPr>
+            <a:fld id="{18B4ECCA-5441-478E-8672-6AB21BB71BD9}" type="slidenum">
+              <a:rPr lang="en-US" altLang="en-US" smtClean="0"/>
+              <a:pPr>
+                <a:defRPr/>
+              </a:pPr>
+              <a:t>10</a:t>
+            </a:fld>
+            <a:endParaRPr lang="en-US" altLang="en-US"/>
+          </a:p>
+        </p:txBody>
+      </p:sp>
+    </p:spTree>
+    <p:extLst>
+      <p:ext uri="{BB962C8B-B14F-4D97-AF65-F5344CB8AC3E}">
+        <p14:creationId xmlns:p14="http://schemas.microsoft.com/office/powerpoint/2010/main" val="1589424273"/>
+      </p:ext>
+    </p:extLst>
+  </p:cSld>
+  <p:clrMapOvr>
+    <a:masterClrMapping/>
+  </p:clrMapOvr>
+</p:notes>
+</file>
+
+<file path=ppt/notesSlides/notesSlide11.xml><?xml version="1.0" encoding="utf-8"?>
+<p:notes xmlns:a="http://schemas.openxmlformats.org/drawingml/2006/main" xmlns:r="http://schemas.openxmlformats.org/officeDocument/2006/relationships" xmlns:p="http://schemas.openxmlformats.org/presentationml/2006/main">
+  <p:cSld>
+    <p:spTree>
+      <p:nvGrpSpPr>
         <p:cNvPr id="1" name="">
           <a:extLst>
             <a:ext uri="{FF2B5EF4-FFF2-40B4-BE49-F238E27FC236}">
@@ -1099,7 +1197,7 @@
               <a:pPr>
                 <a:defRPr/>
               </a:pPr>
-              <a:t>10</a:t>
+              <a:t>11</a:t>
             </a:fld>
             <a:endParaRPr lang="en-US" altLang="en-US"/>
           </a:p>
@@ -1118,7 +1216,7 @@
 </p:notes>
 </file>
 
-<file path=ppt/notesSlides/notesSlide11.xml><?xml version="1.0" encoding="utf-8"?>
+<file path=ppt/notesSlides/notesSlide12.xml><?xml version="1.0" encoding="utf-8"?>
 <p:notes xmlns:a="http://schemas.openxmlformats.org/drawingml/2006/main" xmlns:r="http://schemas.openxmlformats.org/officeDocument/2006/relationships" xmlns:p="http://schemas.openxmlformats.org/presentationml/2006/main">
   <p:cSld>
     <p:spTree>
@@ -1243,7 +1341,7 @@
               <a:pPr>
                 <a:defRPr/>
               </a:pPr>
-              <a:t>11</a:t>
+              <a:t>12</a:t>
             </a:fld>
             <a:endParaRPr lang="en-US" altLang="en-US"/>
           </a:p>
@@ -1262,7 +1360,7 @@
 </p:notes>
 </file>
 
-<file path=ppt/notesSlides/notesSlide12.xml><?xml version="1.0" encoding="utf-8"?>
+<file path=ppt/notesSlides/notesSlide13.xml><?xml version="1.0" encoding="utf-8"?>
 <p:notes xmlns:a="http://schemas.openxmlformats.org/drawingml/2006/main" xmlns:r="http://schemas.openxmlformats.org/officeDocument/2006/relationships" xmlns:p="http://schemas.openxmlformats.org/presentationml/2006/main">
   <p:cSld>
     <p:spTree>
@@ -1387,7 +1485,7 @@
               <a:pPr>
                 <a:defRPr/>
               </a:pPr>
-              <a:t>12</a:t>
+              <a:t>13</a:t>
             </a:fld>
             <a:endParaRPr lang="en-US" altLang="en-US"/>
           </a:p>
@@ -1406,7 +1504,7 @@
 </p:notes>
 </file>
 
-<file path=ppt/notesSlides/notesSlide13.xml><?xml version="1.0" encoding="utf-8"?>
+<file path=ppt/notesSlides/notesSlide14.xml><?xml version="1.0" encoding="utf-8"?>
 <p:notes xmlns:a="http://schemas.openxmlformats.org/drawingml/2006/main" xmlns:r="http://schemas.openxmlformats.org/officeDocument/2006/relationships" xmlns:p="http://schemas.openxmlformats.org/presentationml/2006/main">
   <p:cSld>
     <p:spTree>
@@ -1507,7 +1605,7 @@
               <a:pPr>
                 <a:defRPr/>
               </a:pPr>
-              <a:t>13</a:t>
+              <a:t>14</a:t>
             </a:fld>
             <a:endParaRPr lang="en-US" altLang="en-US"/>
           </a:p>
@@ -1526,7 +1624,7 @@
 </p:notes>
 </file>
 
-<file path=ppt/notesSlides/notesSlide14.xml><?xml version="1.0" encoding="utf-8"?>
+<file path=ppt/notesSlides/notesSlide15.xml><?xml version="1.0" encoding="utf-8"?>
 <p:notes xmlns:a="http://schemas.openxmlformats.org/drawingml/2006/main" xmlns:r="http://schemas.openxmlformats.org/officeDocument/2006/relationships" xmlns:p="http://schemas.openxmlformats.org/presentationml/2006/main">
   <p:cSld>
     <p:spTree>
@@ -1651,7 +1749,7 @@
               <a:pPr>
                 <a:defRPr/>
               </a:pPr>
-              <a:t>14</a:t>
+              <a:t>15</a:t>
             </a:fld>
             <a:endParaRPr lang="en-US" altLang="en-US"/>
           </a:p>
@@ -1670,7 +1768,7 @@
 </p:notes>
 </file>
 
-<file path=ppt/notesSlides/notesSlide15.xml><?xml version="1.0" encoding="utf-8"?>
+<file path=ppt/notesSlides/notesSlide16.xml><?xml version="1.0" encoding="utf-8"?>
 <p:notes xmlns:a="http://schemas.openxmlformats.org/drawingml/2006/main" xmlns:r="http://schemas.openxmlformats.org/officeDocument/2006/relationships" xmlns:p="http://schemas.openxmlformats.org/presentationml/2006/main">
   <p:cSld>
     <p:spTree>
@@ -1795,7 +1893,7 @@
               <a:pPr>
                 <a:defRPr/>
               </a:pPr>
-              <a:t>15</a:t>
+              <a:t>16</a:t>
             </a:fld>
             <a:endParaRPr lang="en-US" altLang="en-US"/>
           </a:p>
@@ -1814,7 +1912,7 @@
 </p:notes>
 </file>
 
-<file path=ppt/notesSlides/notesSlide16.xml><?xml version="1.0" encoding="utf-8"?>
+<file path=ppt/notesSlides/notesSlide17.xml><?xml version="1.0" encoding="utf-8"?>
 <p:notes xmlns:a="http://schemas.openxmlformats.org/drawingml/2006/main" xmlns:r="http://schemas.openxmlformats.org/officeDocument/2006/relationships" xmlns:p="http://schemas.openxmlformats.org/presentationml/2006/main">
   <p:cSld>
     <p:spTree>
@@ -1892,7 +1990,7 @@
               <a:pPr>
                 <a:defRPr/>
               </a:pPr>
-              <a:t>16</a:t>
+              <a:t>17</a:t>
             </a:fld>
             <a:endParaRPr lang="en-US" altLang="en-US"/>
           </a:p>
@@ -1911,7 +2009,7 @@
 </p:notes>
 </file>
 
-<file path=ppt/notesSlides/notesSlide17.xml><?xml version="1.0" encoding="utf-8"?>
+<file path=ppt/notesSlides/notesSlide18.xml><?xml version="1.0" encoding="utf-8"?>
 <p:notes xmlns:a="http://schemas.openxmlformats.org/drawingml/2006/main" xmlns:r="http://schemas.openxmlformats.org/officeDocument/2006/relationships" xmlns:p="http://schemas.openxmlformats.org/presentationml/2006/main">
   <p:cSld>
     <p:spTree>
@@ -2013,7 +2111,7 @@
               <a:pPr>
                 <a:defRPr/>
               </a:pPr>
-              <a:t>17</a:t>
+              <a:t>18</a:t>
             </a:fld>
             <a:endParaRPr lang="en-US" altLang="en-US"/>
           </a:p>
@@ -2032,7 +2130,7 @@
 </p:notes>
 </file>
 
-<file path=ppt/notesSlides/notesSlide18.xml><?xml version="1.0" encoding="utf-8"?>
+<file path=ppt/notesSlides/notesSlide19.xml><?xml version="1.0" encoding="utf-8"?>
 <p:notes xmlns:a="http://schemas.openxmlformats.org/drawingml/2006/main" xmlns:r="http://schemas.openxmlformats.org/officeDocument/2006/relationships" xmlns:p="http://schemas.openxmlformats.org/presentationml/2006/main">
   <p:cSld>
     <p:spTree>
@@ -2157,7 +2255,7 @@
               <a:pPr>
                 <a:defRPr/>
               </a:pPr>
-              <a:t>18</a:t>
+              <a:t>19</a:t>
             </a:fld>
             <a:endParaRPr lang="en-US" altLang="en-US"/>
           </a:p>
@@ -2176,7 +2274,120 @@
 </p:notes>
 </file>
 
-<file path=ppt/notesSlides/notesSlide19.xml><?xml version="1.0" encoding="utf-8"?>
+<file path=ppt/notesSlides/notesSlide2.xml><?xml version="1.0" encoding="utf-8"?>
+<p:notes xmlns:a="http://schemas.openxmlformats.org/drawingml/2006/main" xmlns:r="http://schemas.openxmlformats.org/officeDocument/2006/relationships" xmlns:p="http://schemas.openxmlformats.org/presentationml/2006/main">
+  <p:cSld>
+    <p:spTree>
+      <p:nvGrpSpPr>
+        <p:cNvPr id="1" name="">
+          <a:extLst>
+            <a:ext uri="{FF2B5EF4-FFF2-40B4-BE49-F238E27FC236}">
+              <a16:creationId xmlns:a16="http://schemas.microsoft.com/office/drawing/2014/main" id="{D2535673-0793-1473-0EA1-CD4CB936F95F}"/>
+            </a:ext>
+          </a:extLst>
+        </p:cNvPr>
+        <p:cNvGrpSpPr/>
+        <p:nvPr/>
+      </p:nvGrpSpPr>
+      <p:grpSpPr>
+        <a:xfrm>
+          <a:off x="0" y="0"/>
+          <a:ext cx="0" cy="0"/>
+          <a:chOff x="0" y="0"/>
+          <a:chExt cx="0" cy="0"/>
+        </a:xfrm>
+      </p:grpSpPr>
+      <p:sp>
+        <p:nvSpPr>
+          <p:cNvPr id="2" name="Slide Image Placeholder 1">
+            <a:extLst>
+              <a:ext uri="{FF2B5EF4-FFF2-40B4-BE49-F238E27FC236}">
+                <a16:creationId xmlns:a16="http://schemas.microsoft.com/office/drawing/2014/main" id="{C88EE368-AA1D-B984-B84E-0631B033559A}"/>
+              </a:ext>
+            </a:extLst>
+          </p:cNvPr>
+          <p:cNvSpPr>
+            <a:spLocks noGrp="1" noRot="1" noChangeAspect="1"/>
+          </p:cNvSpPr>
+          <p:nvPr>
+            <p:ph type="sldImg"/>
+          </p:nvPr>
+        </p:nvSpPr>
+        <p:spPr>
+          <a:xfrm>
+            <a:off x="381000" y="685800"/>
+            <a:ext cx="6096000" cy="3429000"/>
+          </a:xfrm>
+        </p:spPr>
+      </p:sp>
+      <p:sp>
+        <p:nvSpPr>
+          <p:cNvPr id="3" name="Notes Placeholder 2">
+            <a:extLst>
+              <a:ext uri="{FF2B5EF4-FFF2-40B4-BE49-F238E27FC236}">
+                <a16:creationId xmlns:a16="http://schemas.microsoft.com/office/drawing/2014/main" id="{85931B74-7FB9-0113-7CD5-66B641609D92}"/>
+              </a:ext>
+            </a:extLst>
+          </p:cNvPr>
+          <p:cNvSpPr>
+            <a:spLocks noGrp="1"/>
+          </p:cNvSpPr>
+          <p:nvPr>
+            <p:ph type="body" idx="1"/>
+          </p:nvPr>
+        </p:nvSpPr>
+        <p:spPr/>
+        <p:txBody>
+          <a:bodyPr/>
+          <a:lstStyle/>
+          <a:p>
+            <a:endParaRPr lang="en-US" dirty="0"/>
+          </a:p>
+        </p:txBody>
+      </p:sp>
+      <p:sp>
+        <p:nvSpPr>
+          <p:cNvPr id="4" name="Slide Number Placeholder 3">
+            <a:extLst>
+              <a:ext uri="{FF2B5EF4-FFF2-40B4-BE49-F238E27FC236}">
+                <a16:creationId xmlns:a16="http://schemas.microsoft.com/office/drawing/2014/main" id="{1C72BFBD-15BB-D615-DB04-14DDDFB65481}"/>
+              </a:ext>
+            </a:extLst>
+          </p:cNvPr>
+          <p:cNvSpPr>
+            <a:spLocks noGrp="1"/>
+          </p:cNvSpPr>
+          <p:nvPr>
+            <p:ph type="sldNum" sz="quarter" idx="5"/>
+          </p:nvPr>
+        </p:nvSpPr>
+        <p:spPr/>
+        <p:txBody>
+          <a:bodyPr/>
+          <a:lstStyle/>
+          <a:p>
+            <a:fld id="{292570D5-C374-43AE-876B-55C2A221664E}" type="slidenum">
+              <a:rPr lang="en-US" smtClean="0"/>
+              <a:t>2</a:t>
+            </a:fld>
+            <a:endParaRPr lang="en-US"/>
+          </a:p>
+        </p:txBody>
+      </p:sp>
+    </p:spTree>
+    <p:extLst>
+      <p:ext uri="{BB962C8B-B14F-4D97-AF65-F5344CB8AC3E}">
+        <p14:creationId xmlns:p14="http://schemas.microsoft.com/office/powerpoint/2010/main" val="3170811600"/>
+      </p:ext>
+    </p:extLst>
+  </p:cSld>
+  <p:clrMapOvr>
+    <a:masterClrMapping/>
+  </p:clrMapOvr>
+</p:notes>
+</file>
+
+<file path=ppt/notesSlides/notesSlide20.xml><?xml version="1.0" encoding="utf-8"?>
 <p:notes xmlns:a="http://schemas.openxmlformats.org/drawingml/2006/main" xmlns:r="http://schemas.openxmlformats.org/officeDocument/2006/relationships" xmlns:p="http://schemas.openxmlformats.org/presentationml/2006/main">
   <p:cSld>
     <p:spTree>
@@ -2254,7 +2465,7 @@
               <a:pPr>
                 <a:defRPr/>
               </a:pPr>
-              <a:t>19</a:t>
+              <a:t>20</a:t>
             </a:fld>
             <a:endParaRPr lang="en-US" altLang="en-US"/>
           </a:p>
@@ -2273,7 +2484,755 @@
 </p:notes>
 </file>
 
-<file path=ppt/notesSlides/notesSlide2.xml><?xml version="1.0" encoding="utf-8"?>
+<file path=ppt/notesSlides/notesSlide21.xml><?xml version="1.0" encoding="utf-8"?>
+<p:notes xmlns:a="http://schemas.openxmlformats.org/drawingml/2006/main" xmlns:r="http://schemas.openxmlformats.org/officeDocument/2006/relationships" xmlns:p="http://schemas.openxmlformats.org/presentationml/2006/main">
+  <p:cSld>
+    <p:spTree>
+      <p:nvGrpSpPr>
+        <p:cNvPr id="1" name="">
+          <a:extLst>
+            <a:ext uri="{FF2B5EF4-FFF2-40B4-BE49-F238E27FC236}">
+              <a16:creationId xmlns:a16="http://schemas.microsoft.com/office/drawing/2014/main" id="{9D231A53-26E7-27EB-AA77-6BCAD42501D1}"/>
+            </a:ext>
+          </a:extLst>
+        </p:cNvPr>
+        <p:cNvGrpSpPr/>
+        <p:nvPr/>
+      </p:nvGrpSpPr>
+      <p:grpSpPr>
+        <a:xfrm>
+          <a:off x="0" y="0"/>
+          <a:ext cx="0" cy="0"/>
+          <a:chOff x="0" y="0"/>
+          <a:chExt cx="0" cy="0"/>
+        </a:xfrm>
+      </p:grpSpPr>
+      <p:sp>
+        <p:nvSpPr>
+          <p:cNvPr id="2" name="Slide Image Placeholder 1">
+            <a:extLst>
+              <a:ext uri="{FF2B5EF4-FFF2-40B4-BE49-F238E27FC236}">
+                <a16:creationId xmlns:a16="http://schemas.microsoft.com/office/drawing/2014/main" id="{13AC93BE-7C9F-D9BE-A094-8FE37C74F4C6}"/>
+              </a:ext>
+            </a:extLst>
+          </p:cNvPr>
+          <p:cNvSpPr>
+            <a:spLocks noGrp="1" noRot="1" noChangeAspect="1"/>
+          </p:cNvSpPr>
+          <p:nvPr>
+            <p:ph type="sldImg"/>
+          </p:nvPr>
+        </p:nvSpPr>
+        <p:spPr>
+          <a:xfrm>
+            <a:off x="381000" y="685800"/>
+            <a:ext cx="6096000" cy="3429000"/>
+          </a:xfrm>
+        </p:spPr>
+      </p:sp>
+      <p:sp>
+        <p:nvSpPr>
+          <p:cNvPr id="3" name="Notes Placeholder 2">
+            <a:extLst>
+              <a:ext uri="{FF2B5EF4-FFF2-40B4-BE49-F238E27FC236}">
+                <a16:creationId xmlns:a16="http://schemas.microsoft.com/office/drawing/2014/main" id="{338D7B24-32A6-C22F-412A-88974C0172DA}"/>
+              </a:ext>
+            </a:extLst>
+          </p:cNvPr>
+          <p:cNvSpPr>
+            <a:spLocks noGrp="1"/>
+          </p:cNvSpPr>
+          <p:nvPr>
+            <p:ph type="body" idx="1"/>
+          </p:nvPr>
+        </p:nvSpPr>
+        <p:spPr/>
+        <p:txBody>
+          <a:bodyPr/>
+          <a:lstStyle/>
+          <a:p>
+            <a:endParaRPr lang="en-US" dirty="0"/>
+          </a:p>
+        </p:txBody>
+      </p:sp>
+      <p:sp>
+        <p:nvSpPr>
+          <p:cNvPr id="4" name="Slide Number Placeholder 3">
+            <a:extLst>
+              <a:ext uri="{FF2B5EF4-FFF2-40B4-BE49-F238E27FC236}">
+                <a16:creationId xmlns:a16="http://schemas.microsoft.com/office/drawing/2014/main" id="{73195394-049D-95B4-D2CD-04ED0AFEEFDA}"/>
+              </a:ext>
+            </a:extLst>
+          </p:cNvPr>
+          <p:cNvSpPr>
+            <a:spLocks noGrp="1"/>
+          </p:cNvSpPr>
+          <p:nvPr>
+            <p:ph type="sldNum" sz="quarter" idx="5"/>
+          </p:nvPr>
+        </p:nvSpPr>
+        <p:spPr/>
+        <p:txBody>
+          <a:bodyPr/>
+          <a:lstStyle/>
+          <a:p>
+            <a:fld id="{292570D5-C374-43AE-876B-55C2A221664E}" type="slidenum">
+              <a:rPr lang="en-US" smtClean="0"/>
+              <a:t>21</a:t>
+            </a:fld>
+            <a:endParaRPr lang="en-US"/>
+          </a:p>
+        </p:txBody>
+      </p:sp>
+    </p:spTree>
+    <p:extLst>
+      <p:ext uri="{BB962C8B-B14F-4D97-AF65-F5344CB8AC3E}">
+        <p14:creationId xmlns:p14="http://schemas.microsoft.com/office/powerpoint/2010/main" val="997511759"/>
+      </p:ext>
+    </p:extLst>
+  </p:cSld>
+  <p:clrMapOvr>
+    <a:masterClrMapping/>
+  </p:clrMapOvr>
+</p:notes>
+</file>
+
+<file path=ppt/notesSlides/notesSlide22.xml><?xml version="1.0" encoding="utf-8"?>
+<p:notes xmlns:a="http://schemas.openxmlformats.org/drawingml/2006/main" xmlns:r="http://schemas.openxmlformats.org/officeDocument/2006/relationships" xmlns:p="http://schemas.openxmlformats.org/presentationml/2006/main">
+  <p:cSld>
+    <p:spTree>
+      <p:nvGrpSpPr>
+        <p:cNvPr id="1" name=""/>
+        <p:cNvGrpSpPr/>
+        <p:nvPr/>
+      </p:nvGrpSpPr>
+      <p:grpSpPr>
+        <a:xfrm>
+          <a:off x="0" y="0"/>
+          <a:ext cx="0" cy="0"/>
+          <a:chOff x="0" y="0"/>
+          <a:chExt cx="0" cy="0"/>
+        </a:xfrm>
+      </p:grpSpPr>
+      <p:sp>
+        <p:nvSpPr>
+          <p:cNvPr id="2" name="Slide Image Placeholder 1"/>
+          <p:cNvSpPr>
+            <a:spLocks noGrp="1" noRot="1" noChangeAspect="1"/>
+          </p:cNvSpPr>
+          <p:nvPr>
+            <p:ph type="sldImg"/>
+          </p:nvPr>
+        </p:nvSpPr>
+        <p:spPr>
+          <a:xfrm>
+            <a:off x="381000" y="685800"/>
+            <a:ext cx="6096000" cy="3429000"/>
+          </a:xfrm>
+        </p:spPr>
+      </p:sp>
+      <p:sp>
+        <p:nvSpPr>
+          <p:cNvPr id="3" name="Notes Placeholder 2"/>
+          <p:cNvSpPr>
+            <a:spLocks noGrp="1"/>
+          </p:cNvSpPr>
+          <p:nvPr>
+            <p:ph type="body" idx="1"/>
+          </p:nvPr>
+        </p:nvSpPr>
+        <p:spPr/>
+        <p:txBody>
+          <a:bodyPr/>
+          <a:lstStyle/>
+          <a:p>
+            <a:r>
+              <a:rPr lang="en-US" dirty="0"/>
+              <a:t>Sous </a:t>
+            </a:r>
+            <a:r>
+              <a:rPr lang="en-US"/>
+              <a:t>Chef Example</a:t>
+            </a:r>
+            <a:endParaRPr lang="en-US" dirty="0"/>
+          </a:p>
+        </p:txBody>
+      </p:sp>
+      <p:sp>
+        <p:nvSpPr>
+          <p:cNvPr id="4" name="Slide Number Placeholder 3"/>
+          <p:cNvSpPr>
+            <a:spLocks noGrp="1"/>
+          </p:cNvSpPr>
+          <p:nvPr>
+            <p:ph type="sldNum" sz="quarter" idx="5"/>
+          </p:nvPr>
+        </p:nvSpPr>
+        <p:spPr/>
+        <p:txBody>
+          <a:bodyPr/>
+          <a:lstStyle/>
+          <a:p>
+            <a:fld id="{292570D5-C374-43AE-876B-55C2A221664E}" type="slidenum">
+              <a:rPr lang="en-US" smtClean="0"/>
+              <a:t>22</a:t>
+            </a:fld>
+            <a:endParaRPr lang="en-US"/>
+          </a:p>
+        </p:txBody>
+      </p:sp>
+    </p:spTree>
+    <p:extLst>
+      <p:ext uri="{BB962C8B-B14F-4D97-AF65-F5344CB8AC3E}">
+        <p14:creationId xmlns:p14="http://schemas.microsoft.com/office/powerpoint/2010/main" val="3851621045"/>
+      </p:ext>
+    </p:extLst>
+  </p:cSld>
+  <p:clrMapOvr>
+    <a:masterClrMapping/>
+  </p:clrMapOvr>
+</p:notes>
+</file>
+
+<file path=ppt/notesSlides/notesSlide23.xml><?xml version="1.0" encoding="utf-8"?>
+<p:notes xmlns:a="http://schemas.openxmlformats.org/drawingml/2006/main" xmlns:r="http://schemas.openxmlformats.org/officeDocument/2006/relationships" xmlns:p="http://schemas.openxmlformats.org/presentationml/2006/main">
+  <p:cSld>
+    <p:spTree>
+      <p:nvGrpSpPr>
+        <p:cNvPr id="1" name=""/>
+        <p:cNvGrpSpPr/>
+        <p:nvPr/>
+      </p:nvGrpSpPr>
+      <p:grpSpPr>
+        <a:xfrm>
+          <a:off x="0" y="0"/>
+          <a:ext cx="0" cy="0"/>
+          <a:chOff x="0" y="0"/>
+          <a:chExt cx="0" cy="0"/>
+        </a:xfrm>
+      </p:grpSpPr>
+      <p:sp>
+        <p:nvSpPr>
+          <p:cNvPr id="2" name="Slide Image Placeholder 1"/>
+          <p:cNvSpPr>
+            <a:spLocks noGrp="1" noRot="1" noChangeAspect="1"/>
+          </p:cNvSpPr>
+          <p:nvPr>
+            <p:ph type="sldImg"/>
+          </p:nvPr>
+        </p:nvSpPr>
+        <p:spPr>
+          <a:xfrm>
+            <a:off x="381000" y="685800"/>
+            <a:ext cx="6096000" cy="3429000"/>
+          </a:xfrm>
+        </p:spPr>
+      </p:sp>
+      <p:sp>
+        <p:nvSpPr>
+          <p:cNvPr id="3" name="Notes Placeholder 2"/>
+          <p:cNvSpPr>
+            <a:spLocks noGrp="1"/>
+          </p:cNvSpPr>
+          <p:nvPr>
+            <p:ph type="body" idx="1"/>
+          </p:nvPr>
+        </p:nvSpPr>
+        <p:spPr/>
+        <p:txBody>
+          <a:bodyPr/>
+          <a:lstStyle/>
+          <a:p>
+            <a:endParaRPr lang="en-US" dirty="0"/>
+          </a:p>
+        </p:txBody>
+      </p:sp>
+      <p:sp>
+        <p:nvSpPr>
+          <p:cNvPr id="4" name="Slide Number Placeholder 3"/>
+          <p:cNvSpPr>
+            <a:spLocks noGrp="1"/>
+          </p:cNvSpPr>
+          <p:nvPr>
+            <p:ph type="sldNum" sz="quarter" idx="5"/>
+          </p:nvPr>
+        </p:nvSpPr>
+        <p:spPr/>
+        <p:txBody>
+          <a:bodyPr/>
+          <a:lstStyle/>
+          <a:p>
+            <a:fld id="{292570D5-C374-43AE-876B-55C2A221664E}" type="slidenum">
+              <a:rPr lang="en-US" smtClean="0"/>
+              <a:t>23</a:t>
+            </a:fld>
+            <a:endParaRPr lang="en-US"/>
+          </a:p>
+        </p:txBody>
+      </p:sp>
+    </p:spTree>
+    <p:extLst>
+      <p:ext uri="{BB962C8B-B14F-4D97-AF65-F5344CB8AC3E}">
+        <p14:creationId xmlns:p14="http://schemas.microsoft.com/office/powerpoint/2010/main" val="3229056280"/>
+      </p:ext>
+    </p:extLst>
+  </p:cSld>
+  <p:clrMapOvr>
+    <a:masterClrMapping/>
+  </p:clrMapOvr>
+</p:notes>
+</file>
+
+<file path=ppt/notesSlides/notesSlide24.xml><?xml version="1.0" encoding="utf-8"?>
+<p:notes xmlns:a="http://schemas.openxmlformats.org/drawingml/2006/main" xmlns:r="http://schemas.openxmlformats.org/officeDocument/2006/relationships" xmlns:p="http://schemas.openxmlformats.org/presentationml/2006/main">
+  <p:cSld>
+    <p:spTree>
+      <p:nvGrpSpPr>
+        <p:cNvPr id="1" name=""/>
+        <p:cNvGrpSpPr/>
+        <p:nvPr/>
+      </p:nvGrpSpPr>
+      <p:grpSpPr>
+        <a:xfrm>
+          <a:off x="0" y="0"/>
+          <a:ext cx="0" cy="0"/>
+          <a:chOff x="0" y="0"/>
+          <a:chExt cx="0" cy="0"/>
+        </a:xfrm>
+      </p:grpSpPr>
+      <p:sp>
+        <p:nvSpPr>
+          <p:cNvPr id="2" name="Slide Image Placeholder 1"/>
+          <p:cNvSpPr>
+            <a:spLocks noGrp="1" noRot="1" noChangeAspect="1"/>
+          </p:cNvSpPr>
+          <p:nvPr>
+            <p:ph type="sldImg"/>
+          </p:nvPr>
+        </p:nvSpPr>
+        <p:spPr>
+          <a:xfrm>
+            <a:off x="381000" y="685800"/>
+            <a:ext cx="6096000" cy="3429000"/>
+          </a:xfrm>
+        </p:spPr>
+      </p:sp>
+      <p:sp>
+        <p:nvSpPr>
+          <p:cNvPr id="3" name="Notes Placeholder 2"/>
+          <p:cNvSpPr>
+            <a:spLocks noGrp="1"/>
+          </p:cNvSpPr>
+          <p:nvPr>
+            <p:ph type="body" idx="1"/>
+          </p:nvPr>
+        </p:nvSpPr>
+        <p:spPr/>
+        <p:txBody>
+          <a:bodyPr/>
+          <a:lstStyle/>
+          <a:p>
+            <a:endParaRPr lang="en-US" dirty="0"/>
+          </a:p>
+        </p:txBody>
+      </p:sp>
+      <p:sp>
+        <p:nvSpPr>
+          <p:cNvPr id="4" name="Slide Number Placeholder 3"/>
+          <p:cNvSpPr>
+            <a:spLocks noGrp="1"/>
+          </p:cNvSpPr>
+          <p:nvPr>
+            <p:ph type="sldNum" sz="quarter" idx="5"/>
+          </p:nvPr>
+        </p:nvSpPr>
+        <p:spPr/>
+        <p:txBody>
+          <a:bodyPr/>
+          <a:lstStyle/>
+          <a:p>
+            <a:fld id="{292570D5-C374-43AE-876B-55C2A221664E}" type="slidenum">
+              <a:rPr lang="en-US" smtClean="0"/>
+              <a:t>24</a:t>
+            </a:fld>
+            <a:endParaRPr lang="en-US"/>
+          </a:p>
+        </p:txBody>
+      </p:sp>
+    </p:spTree>
+    <p:extLst>
+      <p:ext uri="{BB962C8B-B14F-4D97-AF65-F5344CB8AC3E}">
+        <p14:creationId xmlns:p14="http://schemas.microsoft.com/office/powerpoint/2010/main" val="3857445432"/>
+      </p:ext>
+    </p:extLst>
+  </p:cSld>
+  <p:clrMapOvr>
+    <a:masterClrMapping/>
+  </p:clrMapOvr>
+</p:notes>
+</file>
+
+<file path=ppt/notesSlides/notesSlide25.xml><?xml version="1.0" encoding="utf-8"?>
+<p:notes xmlns:a="http://schemas.openxmlformats.org/drawingml/2006/main" xmlns:r="http://schemas.openxmlformats.org/officeDocument/2006/relationships" xmlns:p="http://schemas.openxmlformats.org/presentationml/2006/main">
+  <p:cSld>
+    <p:spTree>
+      <p:nvGrpSpPr>
+        <p:cNvPr id="1" name=""/>
+        <p:cNvGrpSpPr/>
+        <p:nvPr/>
+      </p:nvGrpSpPr>
+      <p:grpSpPr>
+        <a:xfrm>
+          <a:off x="0" y="0"/>
+          <a:ext cx="0" cy="0"/>
+          <a:chOff x="0" y="0"/>
+          <a:chExt cx="0" cy="0"/>
+        </a:xfrm>
+      </p:grpSpPr>
+      <p:sp>
+        <p:nvSpPr>
+          <p:cNvPr id="2" name="Slide Image Placeholder 1"/>
+          <p:cNvSpPr>
+            <a:spLocks noGrp="1" noRot="1" noChangeAspect="1"/>
+          </p:cNvSpPr>
+          <p:nvPr>
+            <p:ph type="sldImg"/>
+          </p:nvPr>
+        </p:nvSpPr>
+        <p:spPr/>
+      </p:sp>
+      <p:sp>
+        <p:nvSpPr>
+          <p:cNvPr id="3" name="Notes Placeholder 2"/>
+          <p:cNvSpPr>
+            <a:spLocks noGrp="1"/>
+          </p:cNvSpPr>
+          <p:nvPr>
+            <p:ph type="body" idx="1"/>
+          </p:nvPr>
+        </p:nvSpPr>
+        <p:spPr/>
+        <p:txBody>
+          <a:bodyPr/>
+          <a:lstStyle/>
+          <a:p>
+            <a:endParaRPr lang="en-US" dirty="0"/>
+          </a:p>
+        </p:txBody>
+      </p:sp>
+      <p:sp>
+        <p:nvSpPr>
+          <p:cNvPr id="4" name="Slide Number Placeholder 3"/>
+          <p:cNvSpPr>
+            <a:spLocks noGrp="1"/>
+          </p:cNvSpPr>
+          <p:nvPr>
+            <p:ph type="sldNum" sz="quarter" idx="5"/>
+          </p:nvPr>
+        </p:nvSpPr>
+        <p:spPr/>
+        <p:txBody>
+          <a:bodyPr/>
+          <a:lstStyle/>
+          <a:p>
+            <a:fld id="{292570D5-C374-43AE-876B-55C2A221664E}" type="slidenum">
+              <a:rPr lang="en-US" smtClean="0"/>
+              <a:t>25</a:t>
+            </a:fld>
+            <a:endParaRPr lang="en-US"/>
+          </a:p>
+        </p:txBody>
+      </p:sp>
+    </p:spTree>
+    <p:extLst>
+      <p:ext uri="{BB962C8B-B14F-4D97-AF65-F5344CB8AC3E}">
+        <p14:creationId xmlns:p14="http://schemas.microsoft.com/office/powerpoint/2010/main" val="516859315"/>
+      </p:ext>
+    </p:extLst>
+  </p:cSld>
+  <p:clrMapOvr>
+    <a:masterClrMapping/>
+  </p:clrMapOvr>
+</p:notes>
+</file>
+
+<file path=ppt/notesSlides/notesSlide26.xml><?xml version="1.0" encoding="utf-8"?>
+<p:notes xmlns:a="http://schemas.openxmlformats.org/drawingml/2006/main" xmlns:r="http://schemas.openxmlformats.org/officeDocument/2006/relationships" xmlns:p="http://schemas.openxmlformats.org/presentationml/2006/main">
+  <p:cSld>
+    <p:spTree>
+      <p:nvGrpSpPr>
+        <p:cNvPr id="1" name=""/>
+        <p:cNvGrpSpPr/>
+        <p:nvPr/>
+      </p:nvGrpSpPr>
+      <p:grpSpPr>
+        <a:xfrm>
+          <a:off x="0" y="0"/>
+          <a:ext cx="0" cy="0"/>
+          <a:chOff x="0" y="0"/>
+          <a:chExt cx="0" cy="0"/>
+        </a:xfrm>
+      </p:grpSpPr>
+      <p:sp>
+        <p:nvSpPr>
+          <p:cNvPr id="2" name="Slide Image Placeholder 1"/>
+          <p:cNvSpPr>
+            <a:spLocks noGrp="1" noRot="1" noChangeAspect="1"/>
+          </p:cNvSpPr>
+          <p:nvPr>
+            <p:ph type="sldImg"/>
+          </p:nvPr>
+        </p:nvSpPr>
+        <p:spPr>
+          <a:xfrm>
+            <a:off x="381000" y="685800"/>
+            <a:ext cx="6096000" cy="3429000"/>
+          </a:xfrm>
+        </p:spPr>
+      </p:sp>
+      <p:sp>
+        <p:nvSpPr>
+          <p:cNvPr id="3" name="Notes Placeholder 2"/>
+          <p:cNvSpPr>
+            <a:spLocks noGrp="1"/>
+          </p:cNvSpPr>
+          <p:nvPr>
+            <p:ph type="body" idx="1"/>
+          </p:nvPr>
+        </p:nvSpPr>
+        <p:spPr/>
+        <p:txBody>
+          <a:bodyPr/>
+          <a:lstStyle/>
+          <a:p>
+            <a:r>
+              <a:rPr lang="en-US" dirty="0"/>
+              <a:t>15 min left</a:t>
+            </a:r>
+          </a:p>
+        </p:txBody>
+      </p:sp>
+      <p:sp>
+        <p:nvSpPr>
+          <p:cNvPr id="4" name="Slide Number Placeholder 3"/>
+          <p:cNvSpPr>
+            <a:spLocks noGrp="1"/>
+          </p:cNvSpPr>
+          <p:nvPr>
+            <p:ph type="sldNum" sz="quarter" idx="5"/>
+          </p:nvPr>
+        </p:nvSpPr>
+        <p:spPr/>
+        <p:txBody>
+          <a:bodyPr/>
+          <a:lstStyle/>
+          <a:p>
+            <a:fld id="{292570D5-C374-43AE-876B-55C2A221664E}" type="slidenum">
+              <a:rPr lang="en-US" smtClean="0"/>
+              <a:t>26</a:t>
+            </a:fld>
+            <a:endParaRPr lang="en-US"/>
+          </a:p>
+        </p:txBody>
+      </p:sp>
+    </p:spTree>
+    <p:extLst>
+      <p:ext uri="{BB962C8B-B14F-4D97-AF65-F5344CB8AC3E}">
+        <p14:creationId xmlns:p14="http://schemas.microsoft.com/office/powerpoint/2010/main" val="4004051242"/>
+      </p:ext>
+    </p:extLst>
+  </p:cSld>
+  <p:clrMapOvr>
+    <a:masterClrMapping/>
+  </p:clrMapOvr>
+</p:notes>
+</file>
+
+<file path=ppt/notesSlides/notesSlide27.xml><?xml version="1.0" encoding="utf-8"?>
+<p:notes xmlns:a="http://schemas.openxmlformats.org/drawingml/2006/main" xmlns:r="http://schemas.openxmlformats.org/officeDocument/2006/relationships" xmlns:p="http://schemas.openxmlformats.org/presentationml/2006/main">
+  <p:cSld>
+    <p:spTree>
+      <p:nvGrpSpPr>
+        <p:cNvPr id="1" name=""/>
+        <p:cNvGrpSpPr/>
+        <p:nvPr/>
+      </p:nvGrpSpPr>
+      <p:grpSpPr>
+        <a:xfrm>
+          <a:off x="0" y="0"/>
+          <a:ext cx="0" cy="0"/>
+          <a:chOff x="0" y="0"/>
+          <a:chExt cx="0" cy="0"/>
+        </a:xfrm>
+      </p:grpSpPr>
+      <p:sp>
+        <p:nvSpPr>
+          <p:cNvPr id="2" name="Slide Image Placeholder 1"/>
+          <p:cNvSpPr>
+            <a:spLocks noGrp="1" noRot="1" noChangeAspect="1"/>
+          </p:cNvSpPr>
+          <p:nvPr>
+            <p:ph type="sldImg"/>
+          </p:nvPr>
+        </p:nvSpPr>
+        <p:spPr>
+          <a:xfrm>
+            <a:off x="381000" y="685800"/>
+            <a:ext cx="6096000" cy="3429000"/>
+          </a:xfrm>
+        </p:spPr>
+      </p:sp>
+      <p:sp>
+        <p:nvSpPr>
+          <p:cNvPr id="3" name="Notes Placeholder 2"/>
+          <p:cNvSpPr>
+            <a:spLocks noGrp="1"/>
+          </p:cNvSpPr>
+          <p:nvPr>
+            <p:ph type="body" idx="1"/>
+          </p:nvPr>
+        </p:nvSpPr>
+        <p:spPr/>
+        <p:txBody>
+          <a:bodyPr/>
+          <a:lstStyle/>
+          <a:p>
+            <a:endParaRPr lang="en-US" dirty="0"/>
+          </a:p>
+        </p:txBody>
+      </p:sp>
+      <p:sp>
+        <p:nvSpPr>
+          <p:cNvPr id="4" name="Slide Number Placeholder 3"/>
+          <p:cNvSpPr>
+            <a:spLocks noGrp="1"/>
+          </p:cNvSpPr>
+          <p:nvPr>
+            <p:ph type="sldNum" sz="quarter" idx="5"/>
+          </p:nvPr>
+        </p:nvSpPr>
+        <p:spPr/>
+        <p:txBody>
+          <a:bodyPr/>
+          <a:lstStyle/>
+          <a:p>
+            <a:fld id="{292570D5-C374-43AE-876B-55C2A221664E}" type="slidenum">
+              <a:rPr lang="en-US" smtClean="0"/>
+              <a:t>27</a:t>
+            </a:fld>
+            <a:endParaRPr lang="en-US"/>
+          </a:p>
+        </p:txBody>
+      </p:sp>
+    </p:spTree>
+    <p:extLst>
+      <p:ext uri="{BB962C8B-B14F-4D97-AF65-F5344CB8AC3E}">
+        <p14:creationId xmlns:p14="http://schemas.microsoft.com/office/powerpoint/2010/main" val="1300406290"/>
+      </p:ext>
+    </p:extLst>
+  </p:cSld>
+  <p:clrMapOvr>
+    <a:masterClrMapping/>
+  </p:clrMapOvr>
+</p:notes>
+</file>
+
+<file path=ppt/notesSlides/notesSlide28.xml><?xml version="1.0" encoding="utf-8"?>
+<p:notes xmlns:a="http://schemas.openxmlformats.org/drawingml/2006/main" xmlns:r="http://schemas.openxmlformats.org/officeDocument/2006/relationships" xmlns:p="http://schemas.openxmlformats.org/presentationml/2006/main">
+  <p:cSld>
+    <p:spTree>
+      <p:nvGrpSpPr>
+        <p:cNvPr id="1" name=""/>
+        <p:cNvGrpSpPr/>
+        <p:nvPr/>
+      </p:nvGrpSpPr>
+      <p:grpSpPr>
+        <a:xfrm>
+          <a:off x="0" y="0"/>
+          <a:ext cx="0" cy="0"/>
+          <a:chOff x="0" y="0"/>
+          <a:chExt cx="0" cy="0"/>
+        </a:xfrm>
+      </p:grpSpPr>
+      <p:sp>
+        <p:nvSpPr>
+          <p:cNvPr id="2" name="Slide Image Placeholder 1"/>
+          <p:cNvSpPr>
+            <a:spLocks noGrp="1" noRot="1" noChangeAspect="1"/>
+          </p:cNvSpPr>
+          <p:nvPr>
+            <p:ph type="sldImg"/>
+          </p:nvPr>
+        </p:nvSpPr>
+        <p:spPr>
+          <a:xfrm>
+            <a:off x="381000" y="685800"/>
+            <a:ext cx="6096000" cy="3429000"/>
+          </a:xfrm>
+        </p:spPr>
+      </p:sp>
+      <p:sp>
+        <p:nvSpPr>
+          <p:cNvPr id="3" name="Notes Placeholder 2"/>
+          <p:cNvSpPr>
+            <a:spLocks noGrp="1"/>
+          </p:cNvSpPr>
+          <p:nvPr>
+            <p:ph type="body" idx="1"/>
+          </p:nvPr>
+        </p:nvSpPr>
+        <p:spPr/>
+        <p:txBody>
+          <a:bodyPr/>
+          <a:lstStyle/>
+          <a:p>
+            <a:endParaRPr lang="en-US" dirty="0"/>
+          </a:p>
+        </p:txBody>
+      </p:sp>
+      <p:sp>
+        <p:nvSpPr>
+          <p:cNvPr id="4" name="Slide Number Placeholder 3"/>
+          <p:cNvSpPr>
+            <a:spLocks noGrp="1"/>
+          </p:cNvSpPr>
+          <p:nvPr>
+            <p:ph type="sldNum" sz="quarter" idx="10"/>
+          </p:nvPr>
+        </p:nvSpPr>
+        <p:spPr/>
+        <p:txBody>
+          <a:bodyPr/>
+          <a:lstStyle/>
+          <a:p>
+            <a:pPr>
+              <a:defRPr/>
+            </a:pPr>
+            <a:fld id="{9BF26720-795C-40C0-8D4A-669747B4E216}" type="slidenum">
+              <a:rPr lang="en-US" altLang="en-US" smtClean="0"/>
+              <a:pPr>
+                <a:defRPr/>
+              </a:pPr>
+              <a:t>29</a:t>
+            </a:fld>
+            <a:endParaRPr lang="en-US" altLang="en-US" dirty="0"/>
+          </a:p>
+        </p:txBody>
+      </p:sp>
+    </p:spTree>
+    <p:extLst>
+      <p:ext uri="{BB962C8B-B14F-4D97-AF65-F5344CB8AC3E}">
+        <p14:creationId xmlns:p14="http://schemas.microsoft.com/office/powerpoint/2010/main" val="2218293498"/>
+      </p:ext>
+    </p:extLst>
+  </p:cSld>
+  <p:clrMapOvr>
+    <a:masterClrMapping/>
+  </p:clrMapOvr>
+</p:notes>
+</file>
+
+<file path=ppt/notesSlides/notesSlide3.xml><?xml version="1.0" encoding="utf-8"?>
 <p:notes xmlns:a="http://schemas.openxmlformats.org/drawingml/2006/main" xmlns:r="http://schemas.openxmlformats.org/officeDocument/2006/relationships" xmlns:p="http://schemas.openxmlformats.org/presentationml/2006/main">
   <p:cSld>
     <p:spTree>
@@ -2367,7 +3326,7 @@
           <a:p>
             <a:fld id="{292570D5-C374-43AE-876B-55C2A221664E}" type="slidenum">
               <a:rPr lang="en-US" smtClean="0"/>
-              <a:t>2</a:t>
+              <a:t>3</a:t>
             </a:fld>
             <a:endParaRPr lang="en-US"/>
           </a:p>
@@ -2386,755 +3345,7 @@
 </p:notes>
 </file>
 
-<file path=ppt/notesSlides/notesSlide20.xml><?xml version="1.0" encoding="utf-8"?>
-<p:notes xmlns:a="http://schemas.openxmlformats.org/drawingml/2006/main" xmlns:r="http://schemas.openxmlformats.org/officeDocument/2006/relationships" xmlns:p="http://schemas.openxmlformats.org/presentationml/2006/main">
-  <p:cSld>
-    <p:spTree>
-      <p:nvGrpSpPr>
-        <p:cNvPr id="1" name="">
-          <a:extLst>
-            <a:ext uri="{FF2B5EF4-FFF2-40B4-BE49-F238E27FC236}">
-              <a16:creationId xmlns:a16="http://schemas.microsoft.com/office/drawing/2014/main" id="{9D231A53-26E7-27EB-AA77-6BCAD42501D1}"/>
-            </a:ext>
-          </a:extLst>
-        </p:cNvPr>
-        <p:cNvGrpSpPr/>
-        <p:nvPr/>
-      </p:nvGrpSpPr>
-      <p:grpSpPr>
-        <a:xfrm>
-          <a:off x="0" y="0"/>
-          <a:ext cx="0" cy="0"/>
-          <a:chOff x="0" y="0"/>
-          <a:chExt cx="0" cy="0"/>
-        </a:xfrm>
-      </p:grpSpPr>
-      <p:sp>
-        <p:nvSpPr>
-          <p:cNvPr id="2" name="Slide Image Placeholder 1">
-            <a:extLst>
-              <a:ext uri="{FF2B5EF4-FFF2-40B4-BE49-F238E27FC236}">
-                <a16:creationId xmlns:a16="http://schemas.microsoft.com/office/drawing/2014/main" id="{13AC93BE-7C9F-D9BE-A094-8FE37C74F4C6}"/>
-              </a:ext>
-            </a:extLst>
-          </p:cNvPr>
-          <p:cNvSpPr>
-            <a:spLocks noGrp="1" noRot="1" noChangeAspect="1"/>
-          </p:cNvSpPr>
-          <p:nvPr>
-            <p:ph type="sldImg"/>
-          </p:nvPr>
-        </p:nvSpPr>
-        <p:spPr>
-          <a:xfrm>
-            <a:off x="381000" y="685800"/>
-            <a:ext cx="6096000" cy="3429000"/>
-          </a:xfrm>
-        </p:spPr>
-      </p:sp>
-      <p:sp>
-        <p:nvSpPr>
-          <p:cNvPr id="3" name="Notes Placeholder 2">
-            <a:extLst>
-              <a:ext uri="{FF2B5EF4-FFF2-40B4-BE49-F238E27FC236}">
-                <a16:creationId xmlns:a16="http://schemas.microsoft.com/office/drawing/2014/main" id="{338D7B24-32A6-C22F-412A-88974C0172DA}"/>
-              </a:ext>
-            </a:extLst>
-          </p:cNvPr>
-          <p:cNvSpPr>
-            <a:spLocks noGrp="1"/>
-          </p:cNvSpPr>
-          <p:nvPr>
-            <p:ph type="body" idx="1"/>
-          </p:nvPr>
-        </p:nvSpPr>
-        <p:spPr/>
-        <p:txBody>
-          <a:bodyPr/>
-          <a:lstStyle/>
-          <a:p>
-            <a:endParaRPr lang="en-US" dirty="0"/>
-          </a:p>
-        </p:txBody>
-      </p:sp>
-      <p:sp>
-        <p:nvSpPr>
-          <p:cNvPr id="4" name="Slide Number Placeholder 3">
-            <a:extLst>
-              <a:ext uri="{FF2B5EF4-FFF2-40B4-BE49-F238E27FC236}">
-                <a16:creationId xmlns:a16="http://schemas.microsoft.com/office/drawing/2014/main" id="{73195394-049D-95B4-D2CD-04ED0AFEEFDA}"/>
-              </a:ext>
-            </a:extLst>
-          </p:cNvPr>
-          <p:cNvSpPr>
-            <a:spLocks noGrp="1"/>
-          </p:cNvSpPr>
-          <p:nvPr>
-            <p:ph type="sldNum" sz="quarter" idx="5"/>
-          </p:nvPr>
-        </p:nvSpPr>
-        <p:spPr/>
-        <p:txBody>
-          <a:bodyPr/>
-          <a:lstStyle/>
-          <a:p>
-            <a:fld id="{292570D5-C374-43AE-876B-55C2A221664E}" type="slidenum">
-              <a:rPr lang="en-US" smtClean="0"/>
-              <a:t>20</a:t>
-            </a:fld>
-            <a:endParaRPr lang="en-US"/>
-          </a:p>
-        </p:txBody>
-      </p:sp>
-    </p:spTree>
-    <p:extLst>
-      <p:ext uri="{BB962C8B-B14F-4D97-AF65-F5344CB8AC3E}">
-        <p14:creationId xmlns:p14="http://schemas.microsoft.com/office/powerpoint/2010/main" val="997511759"/>
-      </p:ext>
-    </p:extLst>
-  </p:cSld>
-  <p:clrMapOvr>
-    <a:masterClrMapping/>
-  </p:clrMapOvr>
-</p:notes>
-</file>
-
-<file path=ppt/notesSlides/notesSlide21.xml><?xml version="1.0" encoding="utf-8"?>
-<p:notes xmlns:a="http://schemas.openxmlformats.org/drawingml/2006/main" xmlns:r="http://schemas.openxmlformats.org/officeDocument/2006/relationships" xmlns:p="http://schemas.openxmlformats.org/presentationml/2006/main">
-  <p:cSld>
-    <p:spTree>
-      <p:nvGrpSpPr>
-        <p:cNvPr id="1" name=""/>
-        <p:cNvGrpSpPr/>
-        <p:nvPr/>
-      </p:nvGrpSpPr>
-      <p:grpSpPr>
-        <a:xfrm>
-          <a:off x="0" y="0"/>
-          <a:ext cx="0" cy="0"/>
-          <a:chOff x="0" y="0"/>
-          <a:chExt cx="0" cy="0"/>
-        </a:xfrm>
-      </p:grpSpPr>
-      <p:sp>
-        <p:nvSpPr>
-          <p:cNvPr id="2" name="Slide Image Placeholder 1"/>
-          <p:cNvSpPr>
-            <a:spLocks noGrp="1" noRot="1" noChangeAspect="1"/>
-          </p:cNvSpPr>
-          <p:nvPr>
-            <p:ph type="sldImg"/>
-          </p:nvPr>
-        </p:nvSpPr>
-        <p:spPr>
-          <a:xfrm>
-            <a:off x="381000" y="685800"/>
-            <a:ext cx="6096000" cy="3429000"/>
-          </a:xfrm>
-        </p:spPr>
-      </p:sp>
-      <p:sp>
-        <p:nvSpPr>
-          <p:cNvPr id="3" name="Notes Placeholder 2"/>
-          <p:cNvSpPr>
-            <a:spLocks noGrp="1"/>
-          </p:cNvSpPr>
-          <p:nvPr>
-            <p:ph type="body" idx="1"/>
-          </p:nvPr>
-        </p:nvSpPr>
-        <p:spPr/>
-        <p:txBody>
-          <a:bodyPr/>
-          <a:lstStyle/>
-          <a:p>
-            <a:r>
-              <a:rPr lang="en-US" dirty="0"/>
-              <a:t>Sous </a:t>
-            </a:r>
-            <a:r>
-              <a:rPr lang="en-US"/>
-              <a:t>Chef Example</a:t>
-            </a:r>
-            <a:endParaRPr lang="en-US" dirty="0"/>
-          </a:p>
-        </p:txBody>
-      </p:sp>
-      <p:sp>
-        <p:nvSpPr>
-          <p:cNvPr id="4" name="Slide Number Placeholder 3"/>
-          <p:cNvSpPr>
-            <a:spLocks noGrp="1"/>
-          </p:cNvSpPr>
-          <p:nvPr>
-            <p:ph type="sldNum" sz="quarter" idx="5"/>
-          </p:nvPr>
-        </p:nvSpPr>
-        <p:spPr/>
-        <p:txBody>
-          <a:bodyPr/>
-          <a:lstStyle/>
-          <a:p>
-            <a:fld id="{292570D5-C374-43AE-876B-55C2A221664E}" type="slidenum">
-              <a:rPr lang="en-US" smtClean="0"/>
-              <a:t>21</a:t>
-            </a:fld>
-            <a:endParaRPr lang="en-US"/>
-          </a:p>
-        </p:txBody>
-      </p:sp>
-    </p:spTree>
-    <p:extLst>
-      <p:ext uri="{BB962C8B-B14F-4D97-AF65-F5344CB8AC3E}">
-        <p14:creationId xmlns:p14="http://schemas.microsoft.com/office/powerpoint/2010/main" val="3851621045"/>
-      </p:ext>
-    </p:extLst>
-  </p:cSld>
-  <p:clrMapOvr>
-    <a:masterClrMapping/>
-  </p:clrMapOvr>
-</p:notes>
-</file>
-
-<file path=ppt/notesSlides/notesSlide22.xml><?xml version="1.0" encoding="utf-8"?>
-<p:notes xmlns:a="http://schemas.openxmlformats.org/drawingml/2006/main" xmlns:r="http://schemas.openxmlformats.org/officeDocument/2006/relationships" xmlns:p="http://schemas.openxmlformats.org/presentationml/2006/main">
-  <p:cSld>
-    <p:spTree>
-      <p:nvGrpSpPr>
-        <p:cNvPr id="1" name=""/>
-        <p:cNvGrpSpPr/>
-        <p:nvPr/>
-      </p:nvGrpSpPr>
-      <p:grpSpPr>
-        <a:xfrm>
-          <a:off x="0" y="0"/>
-          <a:ext cx="0" cy="0"/>
-          <a:chOff x="0" y="0"/>
-          <a:chExt cx="0" cy="0"/>
-        </a:xfrm>
-      </p:grpSpPr>
-      <p:sp>
-        <p:nvSpPr>
-          <p:cNvPr id="2" name="Slide Image Placeholder 1"/>
-          <p:cNvSpPr>
-            <a:spLocks noGrp="1" noRot="1" noChangeAspect="1"/>
-          </p:cNvSpPr>
-          <p:nvPr>
-            <p:ph type="sldImg"/>
-          </p:nvPr>
-        </p:nvSpPr>
-        <p:spPr>
-          <a:xfrm>
-            <a:off x="381000" y="685800"/>
-            <a:ext cx="6096000" cy="3429000"/>
-          </a:xfrm>
-        </p:spPr>
-      </p:sp>
-      <p:sp>
-        <p:nvSpPr>
-          <p:cNvPr id="3" name="Notes Placeholder 2"/>
-          <p:cNvSpPr>
-            <a:spLocks noGrp="1"/>
-          </p:cNvSpPr>
-          <p:nvPr>
-            <p:ph type="body" idx="1"/>
-          </p:nvPr>
-        </p:nvSpPr>
-        <p:spPr/>
-        <p:txBody>
-          <a:bodyPr/>
-          <a:lstStyle/>
-          <a:p>
-            <a:endParaRPr lang="en-US" dirty="0"/>
-          </a:p>
-        </p:txBody>
-      </p:sp>
-      <p:sp>
-        <p:nvSpPr>
-          <p:cNvPr id="4" name="Slide Number Placeholder 3"/>
-          <p:cNvSpPr>
-            <a:spLocks noGrp="1"/>
-          </p:cNvSpPr>
-          <p:nvPr>
-            <p:ph type="sldNum" sz="quarter" idx="5"/>
-          </p:nvPr>
-        </p:nvSpPr>
-        <p:spPr/>
-        <p:txBody>
-          <a:bodyPr/>
-          <a:lstStyle/>
-          <a:p>
-            <a:fld id="{292570D5-C374-43AE-876B-55C2A221664E}" type="slidenum">
-              <a:rPr lang="en-US" smtClean="0"/>
-              <a:t>22</a:t>
-            </a:fld>
-            <a:endParaRPr lang="en-US"/>
-          </a:p>
-        </p:txBody>
-      </p:sp>
-    </p:spTree>
-    <p:extLst>
-      <p:ext uri="{BB962C8B-B14F-4D97-AF65-F5344CB8AC3E}">
-        <p14:creationId xmlns:p14="http://schemas.microsoft.com/office/powerpoint/2010/main" val="3229056280"/>
-      </p:ext>
-    </p:extLst>
-  </p:cSld>
-  <p:clrMapOvr>
-    <a:masterClrMapping/>
-  </p:clrMapOvr>
-</p:notes>
-</file>
-
-<file path=ppt/notesSlides/notesSlide23.xml><?xml version="1.0" encoding="utf-8"?>
-<p:notes xmlns:a="http://schemas.openxmlformats.org/drawingml/2006/main" xmlns:r="http://schemas.openxmlformats.org/officeDocument/2006/relationships" xmlns:p="http://schemas.openxmlformats.org/presentationml/2006/main">
-  <p:cSld>
-    <p:spTree>
-      <p:nvGrpSpPr>
-        <p:cNvPr id="1" name=""/>
-        <p:cNvGrpSpPr/>
-        <p:nvPr/>
-      </p:nvGrpSpPr>
-      <p:grpSpPr>
-        <a:xfrm>
-          <a:off x="0" y="0"/>
-          <a:ext cx="0" cy="0"/>
-          <a:chOff x="0" y="0"/>
-          <a:chExt cx="0" cy="0"/>
-        </a:xfrm>
-      </p:grpSpPr>
-      <p:sp>
-        <p:nvSpPr>
-          <p:cNvPr id="2" name="Slide Image Placeholder 1"/>
-          <p:cNvSpPr>
-            <a:spLocks noGrp="1" noRot="1" noChangeAspect="1"/>
-          </p:cNvSpPr>
-          <p:nvPr>
-            <p:ph type="sldImg"/>
-          </p:nvPr>
-        </p:nvSpPr>
-        <p:spPr>
-          <a:xfrm>
-            <a:off x="381000" y="685800"/>
-            <a:ext cx="6096000" cy="3429000"/>
-          </a:xfrm>
-        </p:spPr>
-      </p:sp>
-      <p:sp>
-        <p:nvSpPr>
-          <p:cNvPr id="3" name="Notes Placeholder 2"/>
-          <p:cNvSpPr>
-            <a:spLocks noGrp="1"/>
-          </p:cNvSpPr>
-          <p:nvPr>
-            <p:ph type="body" idx="1"/>
-          </p:nvPr>
-        </p:nvSpPr>
-        <p:spPr/>
-        <p:txBody>
-          <a:bodyPr/>
-          <a:lstStyle/>
-          <a:p>
-            <a:endParaRPr lang="en-US" dirty="0"/>
-          </a:p>
-        </p:txBody>
-      </p:sp>
-      <p:sp>
-        <p:nvSpPr>
-          <p:cNvPr id="4" name="Slide Number Placeholder 3"/>
-          <p:cNvSpPr>
-            <a:spLocks noGrp="1"/>
-          </p:cNvSpPr>
-          <p:nvPr>
-            <p:ph type="sldNum" sz="quarter" idx="5"/>
-          </p:nvPr>
-        </p:nvSpPr>
-        <p:spPr/>
-        <p:txBody>
-          <a:bodyPr/>
-          <a:lstStyle/>
-          <a:p>
-            <a:fld id="{292570D5-C374-43AE-876B-55C2A221664E}" type="slidenum">
-              <a:rPr lang="en-US" smtClean="0"/>
-              <a:t>23</a:t>
-            </a:fld>
-            <a:endParaRPr lang="en-US"/>
-          </a:p>
-        </p:txBody>
-      </p:sp>
-    </p:spTree>
-    <p:extLst>
-      <p:ext uri="{BB962C8B-B14F-4D97-AF65-F5344CB8AC3E}">
-        <p14:creationId xmlns:p14="http://schemas.microsoft.com/office/powerpoint/2010/main" val="3857445432"/>
-      </p:ext>
-    </p:extLst>
-  </p:cSld>
-  <p:clrMapOvr>
-    <a:masterClrMapping/>
-  </p:clrMapOvr>
-</p:notes>
-</file>
-
-<file path=ppt/notesSlides/notesSlide24.xml><?xml version="1.0" encoding="utf-8"?>
-<p:notes xmlns:a="http://schemas.openxmlformats.org/drawingml/2006/main" xmlns:r="http://schemas.openxmlformats.org/officeDocument/2006/relationships" xmlns:p="http://schemas.openxmlformats.org/presentationml/2006/main">
-  <p:cSld>
-    <p:spTree>
-      <p:nvGrpSpPr>
-        <p:cNvPr id="1" name=""/>
-        <p:cNvGrpSpPr/>
-        <p:nvPr/>
-      </p:nvGrpSpPr>
-      <p:grpSpPr>
-        <a:xfrm>
-          <a:off x="0" y="0"/>
-          <a:ext cx="0" cy="0"/>
-          <a:chOff x="0" y="0"/>
-          <a:chExt cx="0" cy="0"/>
-        </a:xfrm>
-      </p:grpSpPr>
-      <p:sp>
-        <p:nvSpPr>
-          <p:cNvPr id="2" name="Slide Image Placeholder 1"/>
-          <p:cNvSpPr>
-            <a:spLocks noGrp="1" noRot="1" noChangeAspect="1"/>
-          </p:cNvSpPr>
-          <p:nvPr>
-            <p:ph type="sldImg"/>
-          </p:nvPr>
-        </p:nvSpPr>
-        <p:spPr/>
-      </p:sp>
-      <p:sp>
-        <p:nvSpPr>
-          <p:cNvPr id="3" name="Notes Placeholder 2"/>
-          <p:cNvSpPr>
-            <a:spLocks noGrp="1"/>
-          </p:cNvSpPr>
-          <p:nvPr>
-            <p:ph type="body" idx="1"/>
-          </p:nvPr>
-        </p:nvSpPr>
-        <p:spPr/>
-        <p:txBody>
-          <a:bodyPr/>
-          <a:lstStyle/>
-          <a:p>
-            <a:endParaRPr lang="en-US" dirty="0"/>
-          </a:p>
-        </p:txBody>
-      </p:sp>
-      <p:sp>
-        <p:nvSpPr>
-          <p:cNvPr id="4" name="Slide Number Placeholder 3"/>
-          <p:cNvSpPr>
-            <a:spLocks noGrp="1"/>
-          </p:cNvSpPr>
-          <p:nvPr>
-            <p:ph type="sldNum" sz="quarter" idx="5"/>
-          </p:nvPr>
-        </p:nvSpPr>
-        <p:spPr/>
-        <p:txBody>
-          <a:bodyPr/>
-          <a:lstStyle/>
-          <a:p>
-            <a:fld id="{292570D5-C374-43AE-876B-55C2A221664E}" type="slidenum">
-              <a:rPr lang="en-US" smtClean="0"/>
-              <a:t>24</a:t>
-            </a:fld>
-            <a:endParaRPr lang="en-US"/>
-          </a:p>
-        </p:txBody>
-      </p:sp>
-    </p:spTree>
-    <p:extLst>
-      <p:ext uri="{BB962C8B-B14F-4D97-AF65-F5344CB8AC3E}">
-        <p14:creationId xmlns:p14="http://schemas.microsoft.com/office/powerpoint/2010/main" val="516859315"/>
-      </p:ext>
-    </p:extLst>
-  </p:cSld>
-  <p:clrMapOvr>
-    <a:masterClrMapping/>
-  </p:clrMapOvr>
-</p:notes>
-</file>
-
-<file path=ppt/notesSlides/notesSlide25.xml><?xml version="1.0" encoding="utf-8"?>
-<p:notes xmlns:a="http://schemas.openxmlformats.org/drawingml/2006/main" xmlns:r="http://schemas.openxmlformats.org/officeDocument/2006/relationships" xmlns:p="http://schemas.openxmlformats.org/presentationml/2006/main">
-  <p:cSld>
-    <p:spTree>
-      <p:nvGrpSpPr>
-        <p:cNvPr id="1" name=""/>
-        <p:cNvGrpSpPr/>
-        <p:nvPr/>
-      </p:nvGrpSpPr>
-      <p:grpSpPr>
-        <a:xfrm>
-          <a:off x="0" y="0"/>
-          <a:ext cx="0" cy="0"/>
-          <a:chOff x="0" y="0"/>
-          <a:chExt cx="0" cy="0"/>
-        </a:xfrm>
-      </p:grpSpPr>
-      <p:sp>
-        <p:nvSpPr>
-          <p:cNvPr id="2" name="Slide Image Placeholder 1"/>
-          <p:cNvSpPr>
-            <a:spLocks noGrp="1" noRot="1" noChangeAspect="1"/>
-          </p:cNvSpPr>
-          <p:nvPr>
-            <p:ph type="sldImg"/>
-          </p:nvPr>
-        </p:nvSpPr>
-        <p:spPr>
-          <a:xfrm>
-            <a:off x="381000" y="685800"/>
-            <a:ext cx="6096000" cy="3429000"/>
-          </a:xfrm>
-        </p:spPr>
-      </p:sp>
-      <p:sp>
-        <p:nvSpPr>
-          <p:cNvPr id="3" name="Notes Placeholder 2"/>
-          <p:cNvSpPr>
-            <a:spLocks noGrp="1"/>
-          </p:cNvSpPr>
-          <p:nvPr>
-            <p:ph type="body" idx="1"/>
-          </p:nvPr>
-        </p:nvSpPr>
-        <p:spPr/>
-        <p:txBody>
-          <a:bodyPr/>
-          <a:lstStyle/>
-          <a:p>
-            <a:r>
-              <a:rPr lang="en-US" dirty="0"/>
-              <a:t>15 min left</a:t>
-            </a:r>
-          </a:p>
-        </p:txBody>
-      </p:sp>
-      <p:sp>
-        <p:nvSpPr>
-          <p:cNvPr id="4" name="Slide Number Placeholder 3"/>
-          <p:cNvSpPr>
-            <a:spLocks noGrp="1"/>
-          </p:cNvSpPr>
-          <p:nvPr>
-            <p:ph type="sldNum" sz="quarter" idx="5"/>
-          </p:nvPr>
-        </p:nvSpPr>
-        <p:spPr/>
-        <p:txBody>
-          <a:bodyPr/>
-          <a:lstStyle/>
-          <a:p>
-            <a:fld id="{292570D5-C374-43AE-876B-55C2A221664E}" type="slidenum">
-              <a:rPr lang="en-US" smtClean="0"/>
-              <a:t>25</a:t>
-            </a:fld>
-            <a:endParaRPr lang="en-US"/>
-          </a:p>
-        </p:txBody>
-      </p:sp>
-    </p:spTree>
-    <p:extLst>
-      <p:ext uri="{BB962C8B-B14F-4D97-AF65-F5344CB8AC3E}">
-        <p14:creationId xmlns:p14="http://schemas.microsoft.com/office/powerpoint/2010/main" val="4004051242"/>
-      </p:ext>
-    </p:extLst>
-  </p:cSld>
-  <p:clrMapOvr>
-    <a:masterClrMapping/>
-  </p:clrMapOvr>
-</p:notes>
-</file>
-
-<file path=ppt/notesSlides/notesSlide26.xml><?xml version="1.0" encoding="utf-8"?>
-<p:notes xmlns:a="http://schemas.openxmlformats.org/drawingml/2006/main" xmlns:r="http://schemas.openxmlformats.org/officeDocument/2006/relationships" xmlns:p="http://schemas.openxmlformats.org/presentationml/2006/main">
-  <p:cSld>
-    <p:spTree>
-      <p:nvGrpSpPr>
-        <p:cNvPr id="1" name=""/>
-        <p:cNvGrpSpPr/>
-        <p:nvPr/>
-      </p:nvGrpSpPr>
-      <p:grpSpPr>
-        <a:xfrm>
-          <a:off x="0" y="0"/>
-          <a:ext cx="0" cy="0"/>
-          <a:chOff x="0" y="0"/>
-          <a:chExt cx="0" cy="0"/>
-        </a:xfrm>
-      </p:grpSpPr>
-      <p:sp>
-        <p:nvSpPr>
-          <p:cNvPr id="2" name="Slide Image Placeholder 1"/>
-          <p:cNvSpPr>
-            <a:spLocks noGrp="1" noRot="1" noChangeAspect="1"/>
-          </p:cNvSpPr>
-          <p:nvPr>
-            <p:ph type="sldImg"/>
-          </p:nvPr>
-        </p:nvSpPr>
-        <p:spPr>
-          <a:xfrm>
-            <a:off x="381000" y="685800"/>
-            <a:ext cx="6096000" cy="3429000"/>
-          </a:xfrm>
-        </p:spPr>
-      </p:sp>
-      <p:sp>
-        <p:nvSpPr>
-          <p:cNvPr id="3" name="Notes Placeholder 2"/>
-          <p:cNvSpPr>
-            <a:spLocks noGrp="1"/>
-          </p:cNvSpPr>
-          <p:nvPr>
-            <p:ph type="body" idx="1"/>
-          </p:nvPr>
-        </p:nvSpPr>
-        <p:spPr/>
-        <p:txBody>
-          <a:bodyPr/>
-          <a:lstStyle/>
-          <a:p>
-            <a:endParaRPr lang="en-US" dirty="0"/>
-          </a:p>
-        </p:txBody>
-      </p:sp>
-      <p:sp>
-        <p:nvSpPr>
-          <p:cNvPr id="4" name="Slide Number Placeholder 3"/>
-          <p:cNvSpPr>
-            <a:spLocks noGrp="1"/>
-          </p:cNvSpPr>
-          <p:nvPr>
-            <p:ph type="sldNum" sz="quarter" idx="5"/>
-          </p:nvPr>
-        </p:nvSpPr>
-        <p:spPr/>
-        <p:txBody>
-          <a:bodyPr/>
-          <a:lstStyle/>
-          <a:p>
-            <a:fld id="{292570D5-C374-43AE-876B-55C2A221664E}" type="slidenum">
-              <a:rPr lang="en-US" smtClean="0"/>
-              <a:t>26</a:t>
-            </a:fld>
-            <a:endParaRPr lang="en-US"/>
-          </a:p>
-        </p:txBody>
-      </p:sp>
-    </p:spTree>
-    <p:extLst>
-      <p:ext uri="{BB962C8B-B14F-4D97-AF65-F5344CB8AC3E}">
-        <p14:creationId xmlns:p14="http://schemas.microsoft.com/office/powerpoint/2010/main" val="1300406290"/>
-      </p:ext>
-    </p:extLst>
-  </p:cSld>
-  <p:clrMapOvr>
-    <a:masterClrMapping/>
-  </p:clrMapOvr>
-</p:notes>
-</file>
-
-<file path=ppt/notesSlides/notesSlide27.xml><?xml version="1.0" encoding="utf-8"?>
-<p:notes xmlns:a="http://schemas.openxmlformats.org/drawingml/2006/main" xmlns:r="http://schemas.openxmlformats.org/officeDocument/2006/relationships" xmlns:p="http://schemas.openxmlformats.org/presentationml/2006/main">
-  <p:cSld>
-    <p:spTree>
-      <p:nvGrpSpPr>
-        <p:cNvPr id="1" name=""/>
-        <p:cNvGrpSpPr/>
-        <p:nvPr/>
-      </p:nvGrpSpPr>
-      <p:grpSpPr>
-        <a:xfrm>
-          <a:off x="0" y="0"/>
-          <a:ext cx="0" cy="0"/>
-          <a:chOff x="0" y="0"/>
-          <a:chExt cx="0" cy="0"/>
-        </a:xfrm>
-      </p:grpSpPr>
-      <p:sp>
-        <p:nvSpPr>
-          <p:cNvPr id="2" name="Slide Image Placeholder 1"/>
-          <p:cNvSpPr>
-            <a:spLocks noGrp="1" noRot="1" noChangeAspect="1"/>
-          </p:cNvSpPr>
-          <p:nvPr>
-            <p:ph type="sldImg"/>
-          </p:nvPr>
-        </p:nvSpPr>
-        <p:spPr>
-          <a:xfrm>
-            <a:off x="381000" y="685800"/>
-            <a:ext cx="6096000" cy="3429000"/>
-          </a:xfrm>
-        </p:spPr>
-      </p:sp>
-      <p:sp>
-        <p:nvSpPr>
-          <p:cNvPr id="3" name="Notes Placeholder 2"/>
-          <p:cNvSpPr>
-            <a:spLocks noGrp="1"/>
-          </p:cNvSpPr>
-          <p:nvPr>
-            <p:ph type="body" idx="1"/>
-          </p:nvPr>
-        </p:nvSpPr>
-        <p:spPr/>
-        <p:txBody>
-          <a:bodyPr/>
-          <a:lstStyle/>
-          <a:p>
-            <a:endParaRPr lang="en-US" dirty="0"/>
-          </a:p>
-        </p:txBody>
-      </p:sp>
-      <p:sp>
-        <p:nvSpPr>
-          <p:cNvPr id="4" name="Slide Number Placeholder 3"/>
-          <p:cNvSpPr>
-            <a:spLocks noGrp="1"/>
-          </p:cNvSpPr>
-          <p:nvPr>
-            <p:ph type="sldNum" sz="quarter" idx="10"/>
-          </p:nvPr>
-        </p:nvSpPr>
-        <p:spPr/>
-        <p:txBody>
-          <a:bodyPr/>
-          <a:lstStyle/>
-          <a:p>
-            <a:pPr>
-              <a:defRPr/>
-            </a:pPr>
-            <a:fld id="{9BF26720-795C-40C0-8D4A-669747B4E216}" type="slidenum">
-              <a:rPr lang="en-US" altLang="en-US" smtClean="0"/>
-              <a:pPr>
-                <a:defRPr/>
-              </a:pPr>
-              <a:t>28</a:t>
-            </a:fld>
-            <a:endParaRPr lang="en-US" altLang="en-US" dirty="0"/>
-          </a:p>
-        </p:txBody>
-      </p:sp>
-    </p:spTree>
-    <p:extLst>
-      <p:ext uri="{BB962C8B-B14F-4D97-AF65-F5344CB8AC3E}">
-        <p14:creationId xmlns:p14="http://schemas.microsoft.com/office/powerpoint/2010/main" val="2218293498"/>
-      </p:ext>
-    </p:extLst>
-  </p:cSld>
-  <p:clrMapOvr>
-    <a:masterClrMapping/>
-  </p:clrMapOvr>
-</p:notes>
-</file>
-
-<file path=ppt/notesSlides/notesSlide3.xml><?xml version="1.0" encoding="utf-8"?>
+<file path=ppt/notesSlides/notesSlide4.xml><?xml version="1.0" encoding="utf-8"?>
 <p:notes xmlns:a="http://schemas.openxmlformats.org/drawingml/2006/main" xmlns:r="http://schemas.openxmlformats.org/officeDocument/2006/relationships" xmlns:p="http://schemas.openxmlformats.org/presentationml/2006/main">
   <p:cSld>
     <p:spTree>
@@ -3228,7 +3439,7 @@
           <a:p>
             <a:fld id="{292570D5-C374-43AE-876B-55C2A221664E}" type="slidenum">
               <a:rPr lang="en-US" smtClean="0"/>
-              <a:t>3</a:t>
+              <a:t>4</a:t>
             </a:fld>
             <a:endParaRPr lang="en-US"/>
           </a:p>
@@ -3247,7 +3458,7 @@
 </p:notes>
 </file>
 
-<file path=ppt/notesSlides/notesSlide4.xml><?xml version="1.0" encoding="utf-8"?>
+<file path=ppt/notesSlides/notesSlide5.xml><?xml version="1.0" encoding="utf-8"?>
 <p:notes xmlns:a="http://schemas.openxmlformats.org/drawingml/2006/main" xmlns:r="http://schemas.openxmlformats.org/officeDocument/2006/relationships" xmlns:p="http://schemas.openxmlformats.org/presentationml/2006/main">
   <p:cSld>
     <p:spTree>
@@ -3341,7 +3552,7 @@
           <a:p>
             <a:fld id="{292570D5-C374-43AE-876B-55C2A221664E}" type="slidenum">
               <a:rPr lang="en-US" smtClean="0"/>
-              <a:t>4</a:t>
+              <a:t>5</a:t>
             </a:fld>
             <a:endParaRPr lang="en-US"/>
           </a:p>
@@ -3360,7 +3571,7 @@
 </p:notes>
 </file>
 
-<file path=ppt/notesSlides/notesSlide5.xml><?xml version="1.0" encoding="utf-8"?>
+<file path=ppt/notesSlides/notesSlide6.xml><?xml version="1.0" encoding="utf-8"?>
 <p:notes xmlns:a="http://schemas.openxmlformats.org/drawingml/2006/main" xmlns:r="http://schemas.openxmlformats.org/officeDocument/2006/relationships" xmlns:p="http://schemas.openxmlformats.org/presentationml/2006/main">
   <p:cSld>
     <p:spTree>
@@ -3454,7 +3665,7 @@
           <a:p>
             <a:fld id="{292570D5-C374-43AE-876B-55C2A221664E}" type="slidenum">
               <a:rPr lang="en-US" smtClean="0"/>
-              <a:t>5</a:t>
+              <a:t>6</a:t>
             </a:fld>
             <a:endParaRPr lang="en-US"/>
           </a:p>
@@ -3473,7 +3684,7 @@
 </p:notes>
 </file>
 
-<file path=ppt/notesSlides/notesSlide6.xml><?xml version="1.0" encoding="utf-8"?>
+<file path=ppt/notesSlides/notesSlide7.xml><?xml version="1.0" encoding="utf-8"?>
 <p:notes xmlns:a="http://schemas.openxmlformats.org/drawingml/2006/main" xmlns:r="http://schemas.openxmlformats.org/officeDocument/2006/relationships" xmlns:p="http://schemas.openxmlformats.org/presentationml/2006/main" showMasterSp="0" showMasterPhAnim="0">
   <p:cSld>
     <p:spTree>
@@ -3577,7 +3788,7 @@
 </p:notes>
 </file>
 
-<file path=ppt/notesSlides/notesSlide7.xml><?xml version="1.0" encoding="utf-8"?>
+<file path=ppt/notesSlides/notesSlide8.xml><?xml version="1.0" encoding="utf-8"?>
 <p:notes xmlns:a="http://schemas.openxmlformats.org/drawingml/2006/main" xmlns:r="http://schemas.openxmlformats.org/officeDocument/2006/relationships" xmlns:p="http://schemas.openxmlformats.org/presentationml/2006/main" showMasterSp="0" showMasterPhAnim="0">
   <p:cSld>
     <p:spTree>
@@ -3681,7 +3892,7 @@
 </p:notes>
 </file>
 
-<file path=ppt/notesSlides/notesSlide8.xml><?xml version="1.0" encoding="utf-8"?>
+<file path=ppt/notesSlides/notesSlide9.xml><?xml version="1.0" encoding="utf-8"?>
 <p:notes xmlns:a="http://schemas.openxmlformats.org/drawingml/2006/main" xmlns:r="http://schemas.openxmlformats.org/officeDocument/2006/relationships" xmlns:p="http://schemas.openxmlformats.org/presentationml/2006/main">
   <p:cSld>
     <p:spTree>
@@ -3775,7 +3986,7 @@
           <a:p>
             <a:fld id="{292570D5-C374-43AE-876B-55C2A221664E}" type="slidenum">
               <a:rPr lang="en-US" smtClean="0"/>
-              <a:t>8</a:t>
+              <a:t>9</a:t>
             </a:fld>
             <a:endParaRPr lang="en-US"/>
           </a:p>
@@ -3785,103 +3996,6 @@
     <p:extLst>
       <p:ext uri="{BB962C8B-B14F-4D97-AF65-F5344CB8AC3E}">
         <p14:creationId xmlns:p14="http://schemas.microsoft.com/office/powerpoint/2010/main" val="3132268845"/>
-      </p:ext>
-    </p:extLst>
-  </p:cSld>
-  <p:clrMapOvr>
-    <a:masterClrMapping/>
-  </p:clrMapOvr>
-</p:notes>
-</file>
-
-<file path=ppt/notesSlides/notesSlide9.xml><?xml version="1.0" encoding="utf-8"?>
-<p:notes xmlns:a="http://schemas.openxmlformats.org/drawingml/2006/main" xmlns:r="http://schemas.openxmlformats.org/officeDocument/2006/relationships" xmlns:p="http://schemas.openxmlformats.org/presentationml/2006/main">
-  <p:cSld>
-    <p:spTree>
-      <p:nvGrpSpPr>
-        <p:cNvPr id="1" name=""/>
-        <p:cNvGrpSpPr/>
-        <p:nvPr/>
-      </p:nvGrpSpPr>
-      <p:grpSpPr>
-        <a:xfrm>
-          <a:off x="0" y="0"/>
-          <a:ext cx="0" cy="0"/>
-          <a:chOff x="0" y="0"/>
-          <a:chExt cx="0" cy="0"/>
-        </a:xfrm>
-      </p:grpSpPr>
-      <p:sp>
-        <p:nvSpPr>
-          <p:cNvPr id="2" name="Slide Image Placeholder 1"/>
-          <p:cNvSpPr>
-            <a:spLocks noGrp="1" noRot="1" noChangeAspect="1"/>
-          </p:cNvSpPr>
-          <p:nvPr>
-            <p:ph type="sldImg"/>
-          </p:nvPr>
-        </p:nvSpPr>
-        <p:spPr>
-          <a:xfrm>
-            <a:off x="381000" y="685800"/>
-            <a:ext cx="6096000" cy="3429000"/>
-          </a:xfrm>
-        </p:spPr>
-      </p:sp>
-      <p:sp>
-        <p:nvSpPr>
-          <p:cNvPr id="3" name="Notes Placeholder 2"/>
-          <p:cNvSpPr>
-            <a:spLocks noGrp="1"/>
-          </p:cNvSpPr>
-          <p:nvPr>
-            <p:ph type="body" idx="1"/>
-          </p:nvPr>
-        </p:nvSpPr>
-        <p:spPr/>
-        <p:txBody>
-          <a:bodyPr>
-            <a:normAutofit/>
-          </a:bodyPr>
-          <a:lstStyle/>
-          <a:p>
-            <a:endParaRPr lang="en-US" dirty="0"/>
-          </a:p>
-        </p:txBody>
-      </p:sp>
-      <p:sp>
-        <p:nvSpPr>
-          <p:cNvPr id="4" name="Slide Number Placeholder 3"/>
-          <p:cNvSpPr>
-            <a:spLocks noGrp="1"/>
-          </p:cNvSpPr>
-          <p:nvPr>
-            <p:ph type="sldNum" sz="quarter" idx="5"/>
-          </p:nvPr>
-        </p:nvSpPr>
-        <p:spPr/>
-        <p:txBody>
-          <a:bodyPr/>
-          <a:lstStyle/>
-          <a:p>
-            <a:pPr>
-              <a:defRPr/>
-            </a:pPr>
-            <a:fld id="{18B4ECCA-5441-478E-8672-6AB21BB71BD9}" type="slidenum">
-              <a:rPr lang="en-US" altLang="en-US" smtClean="0"/>
-              <a:pPr>
-                <a:defRPr/>
-              </a:pPr>
-              <a:t>9</a:t>
-            </a:fld>
-            <a:endParaRPr lang="en-US" altLang="en-US"/>
-          </a:p>
-        </p:txBody>
-      </p:sp>
-    </p:spTree>
-    <p:extLst>
-      <p:ext uri="{BB962C8B-B14F-4D97-AF65-F5344CB8AC3E}">
-        <p14:creationId xmlns:p14="http://schemas.microsoft.com/office/powerpoint/2010/main" val="1589424273"/>
       </p:ext>
     </p:extLst>
   </p:cSld>
@@ -46328,6 +46442,99 @@
   <p:cSld>
     <p:spTree>
       <p:nvGrpSpPr>
+        <p:cNvPr id="1" name=""/>
+        <p:cNvGrpSpPr/>
+        <p:nvPr/>
+      </p:nvGrpSpPr>
+      <p:grpSpPr>
+        <a:xfrm>
+          <a:off x="0" y="0"/>
+          <a:ext cx="0" cy="0"/>
+          <a:chOff x="0" y="0"/>
+          <a:chExt cx="0" cy="0"/>
+        </a:xfrm>
+      </p:grpSpPr>
+      <p:sp>
+        <p:nvSpPr>
+          <p:cNvPr id="4" name="Slide Number Placeholder 3">
+            <a:extLst>
+              <a:ext uri="{FF2B5EF4-FFF2-40B4-BE49-F238E27FC236}">
+                <a16:creationId xmlns:a16="http://schemas.microsoft.com/office/drawing/2014/main" id="{D0F0E6DB-EE9E-45C5-B784-49ED7052A2EB}"/>
+              </a:ext>
+            </a:extLst>
+          </p:cNvPr>
+          <p:cNvSpPr>
+            <a:spLocks noGrp="1"/>
+          </p:cNvSpPr>
+          <p:nvPr>
+            <p:ph type="sldNum" sz="quarter" idx="4"/>
+          </p:nvPr>
+        </p:nvSpPr>
+        <p:spPr/>
+        <p:txBody>
+          <a:bodyPr/>
+          <a:lstStyle/>
+          <a:p>
+            <a:fld id="{71B8893A-F325-44A6-8EFB-883C20332CFE}" type="slidenum">
+              <a:rPr lang="en-US" smtClean="0"/>
+              <a:pPr/>
+              <a:t>10</a:t>
+            </a:fld>
+            <a:endParaRPr lang="en-US"/>
+          </a:p>
+        </p:txBody>
+      </p:sp>
+      <p:sp>
+        <p:nvSpPr>
+          <p:cNvPr id="3" name="Title 2">
+            <a:extLst>
+              <a:ext uri="{FF2B5EF4-FFF2-40B4-BE49-F238E27FC236}">
+                <a16:creationId xmlns:a16="http://schemas.microsoft.com/office/drawing/2014/main" id="{DA67ABD9-8A31-4CB9-94E1-A0DA84E71640}"/>
+              </a:ext>
+            </a:extLst>
+          </p:cNvPr>
+          <p:cNvSpPr>
+            <a:spLocks noGrp="1"/>
+          </p:cNvSpPr>
+          <p:nvPr>
+            <p:ph type="title"/>
+          </p:nvPr>
+        </p:nvSpPr>
+        <p:spPr>
+          <a:xfrm>
+            <a:off x="381000" y="1857375"/>
+            <a:ext cx="8382000" cy="857250"/>
+          </a:xfrm>
+        </p:spPr>
+        <p:txBody>
+          <a:bodyPr/>
+          <a:lstStyle/>
+          <a:p>
+            <a:r>
+              <a:rPr lang="en-US" dirty="0"/>
+              <a:t>What are some built-in Python functions that we have learned about?</a:t>
+            </a:r>
+          </a:p>
+        </p:txBody>
+      </p:sp>
+    </p:spTree>
+    <p:extLst>
+      <p:ext uri="{BB962C8B-B14F-4D97-AF65-F5344CB8AC3E}">
+        <p14:creationId xmlns:p14="http://schemas.microsoft.com/office/powerpoint/2010/main" val="1359797099"/>
+      </p:ext>
+    </p:extLst>
+  </p:cSld>
+  <p:clrMapOvr>
+    <a:masterClrMapping/>
+  </p:clrMapOvr>
+</p:sld>
+</file>
+
+<file path=ppt/slides/slide11.xml><?xml version="1.0" encoding="utf-8"?>
+<p:sld xmlns:a="http://schemas.openxmlformats.org/drawingml/2006/main" xmlns:r="http://schemas.openxmlformats.org/officeDocument/2006/relationships" xmlns:p="http://schemas.openxmlformats.org/presentationml/2006/main">
+  <p:cSld>
+    <p:spTree>
+      <p:nvGrpSpPr>
         <p:cNvPr id="1" name="">
           <a:extLst>
             <a:ext uri="{FF2B5EF4-FFF2-40B4-BE49-F238E27FC236}">
@@ -46370,7 +46577,7 @@
             <a:fld id="{71B8893A-F325-44A6-8EFB-883C20332CFE}" type="slidenum">
               <a:rPr lang="en-US" smtClean="0"/>
               <a:pPr/>
-              <a:t>10</a:t>
+              <a:t>11</a:t>
             </a:fld>
             <a:endParaRPr lang="en-US"/>
           </a:p>
@@ -46422,7 +46629,7 @@
 </p:sld>
 </file>
 
-<file path=ppt/slides/slide11.xml><?xml version="1.0" encoding="utf-8"?>
+<file path=ppt/slides/slide12.xml><?xml version="1.0" encoding="utf-8"?>
 <p:sld xmlns:a="http://schemas.openxmlformats.org/drawingml/2006/main" xmlns:r="http://schemas.openxmlformats.org/officeDocument/2006/relationships" xmlns:p="http://schemas.openxmlformats.org/presentationml/2006/main">
   <p:cSld>
     <p:spTree>
@@ -46469,7 +46676,7 @@
             <a:fld id="{71B8893A-F325-44A6-8EFB-883C20332CFE}" type="slidenum">
               <a:rPr lang="en-US" smtClean="0"/>
               <a:pPr/>
-              <a:t>11</a:t>
+              <a:t>12</a:t>
             </a:fld>
             <a:endParaRPr lang="en-US"/>
           </a:p>
@@ -46644,7 +46851,7 @@
 </p:sld>
 </file>
 
-<file path=ppt/slides/slide12.xml><?xml version="1.0" encoding="utf-8"?>
+<file path=ppt/slides/slide13.xml><?xml version="1.0" encoding="utf-8"?>
 <p:sld xmlns:a="http://schemas.openxmlformats.org/drawingml/2006/main" xmlns:r="http://schemas.openxmlformats.org/officeDocument/2006/relationships" xmlns:p="http://schemas.openxmlformats.org/presentationml/2006/main">
   <p:cSld>
     <p:spTree>
@@ -46691,7 +46898,7 @@
             <a:fld id="{71B8893A-F325-44A6-8EFB-883C20332CFE}" type="slidenum">
               <a:rPr lang="en-US" smtClean="0"/>
               <a:pPr/>
-              <a:t>12</a:t>
+              <a:t>13</a:t>
             </a:fld>
             <a:endParaRPr lang="en-US"/>
           </a:p>
@@ -47020,7 +47227,7 @@
 </p:sld>
 </file>
 
-<file path=ppt/slides/slide13.xml><?xml version="1.0" encoding="utf-8"?>
+<file path=ppt/slides/slide14.xml><?xml version="1.0" encoding="utf-8"?>
 <p:sld xmlns:a="http://schemas.openxmlformats.org/drawingml/2006/main" xmlns:r="http://schemas.openxmlformats.org/officeDocument/2006/relationships" xmlns:p="http://schemas.openxmlformats.org/presentationml/2006/main">
   <p:cSld>
     <p:spTree>
@@ -47061,7 +47268,7 @@
             <a:fld id="{71B8893A-F325-44A6-8EFB-883C20332CFE}" type="slidenum">
               <a:rPr lang="en-US" smtClean="0"/>
               <a:pPr/>
-              <a:t>13</a:t>
+              <a:t>14</a:t>
             </a:fld>
             <a:endParaRPr lang="en-US"/>
           </a:p>
@@ -47146,7 +47353,7 @@
 </p:sld>
 </file>
 
-<file path=ppt/slides/slide14.xml><?xml version="1.0" encoding="utf-8"?>
+<file path=ppt/slides/slide15.xml><?xml version="1.0" encoding="utf-8"?>
 <p:sld xmlns:a="http://schemas.openxmlformats.org/drawingml/2006/main" xmlns:r="http://schemas.openxmlformats.org/officeDocument/2006/relationships" xmlns:p="http://schemas.openxmlformats.org/presentationml/2006/main">
   <p:cSld>
     <p:spTree>
@@ -47193,7 +47400,7 @@
             <a:fld id="{71B8893A-F325-44A6-8EFB-883C20332CFE}" type="slidenum">
               <a:rPr lang="en-US" smtClean="0"/>
               <a:pPr/>
-              <a:t>14</a:t>
+              <a:t>15</a:t>
             </a:fld>
             <a:endParaRPr lang="en-US"/>
           </a:p>
@@ -47457,7 +47664,7 @@
 </p:sld>
 </file>
 
-<file path=ppt/slides/slide15.xml><?xml version="1.0" encoding="utf-8"?>
+<file path=ppt/slides/slide16.xml><?xml version="1.0" encoding="utf-8"?>
 <p:sld xmlns:a="http://schemas.openxmlformats.org/drawingml/2006/main" xmlns:r="http://schemas.openxmlformats.org/officeDocument/2006/relationships" xmlns:p="http://schemas.openxmlformats.org/presentationml/2006/main">
   <p:cSld>
     <p:spTree>
@@ -47504,7 +47711,7 @@
             <a:fld id="{71B8893A-F325-44A6-8EFB-883C20332CFE}" type="slidenum">
               <a:rPr lang="en-US" smtClean="0"/>
               <a:pPr/>
-              <a:t>15</a:t>
+              <a:t>16</a:t>
             </a:fld>
             <a:endParaRPr lang="en-US"/>
           </a:p>
@@ -47945,7 +48152,7 @@
 </p:sld>
 </file>
 
-<file path=ppt/slides/slide16.xml><?xml version="1.0" encoding="utf-8"?>
+<file path=ppt/slides/slide17.xml><?xml version="1.0" encoding="utf-8"?>
 <p:sld xmlns:a="http://schemas.openxmlformats.org/drawingml/2006/main" xmlns:r="http://schemas.openxmlformats.org/officeDocument/2006/relationships" xmlns:p="http://schemas.openxmlformats.org/presentationml/2006/main">
   <p:cSld>
     <p:spTree>
@@ -47986,7 +48193,7 @@
             <a:fld id="{71B8893A-F325-44A6-8EFB-883C20332CFE}" type="slidenum">
               <a:rPr lang="en-US" smtClean="0"/>
               <a:pPr/>
-              <a:t>16</a:t>
+              <a:t>17</a:t>
             </a:fld>
             <a:endParaRPr lang="en-US"/>
           </a:p>
@@ -48072,7 +48279,7 @@
 </p:sld>
 </file>
 
-<file path=ppt/slides/slide17.xml><?xml version="1.0" encoding="utf-8"?>
+<file path=ppt/slides/slide18.xml><?xml version="1.0" encoding="utf-8"?>
 <p:sld xmlns:a="http://schemas.openxmlformats.org/drawingml/2006/main" xmlns:r="http://schemas.openxmlformats.org/officeDocument/2006/relationships" xmlns:p="http://schemas.openxmlformats.org/presentationml/2006/main">
   <p:cSld>
     <p:spTree>
@@ -48119,7 +48326,7 @@
             <a:fld id="{71B8893A-F325-44A6-8EFB-883C20332CFE}" type="slidenum">
               <a:rPr lang="en-US" smtClean="0"/>
               <a:pPr/>
-              <a:t>17</a:t>
+              <a:t>18</a:t>
             </a:fld>
             <a:endParaRPr lang="en-US"/>
           </a:p>
@@ -48208,7 +48415,7 @@
 </p:sld>
 </file>
 
-<file path=ppt/slides/slide18.xml><?xml version="1.0" encoding="utf-8"?>
+<file path=ppt/slides/slide19.xml><?xml version="1.0" encoding="utf-8"?>
 <p:sld xmlns:a="http://schemas.openxmlformats.org/drawingml/2006/main" xmlns:r="http://schemas.openxmlformats.org/officeDocument/2006/relationships" xmlns:p="http://schemas.openxmlformats.org/presentationml/2006/main">
   <p:cSld>
     <p:spTree>
@@ -48255,7 +48462,7 @@
             <a:fld id="{71B8893A-F325-44A6-8EFB-883C20332CFE}" type="slidenum">
               <a:rPr lang="en-US" smtClean="0"/>
               <a:pPr/>
-              <a:t>18</a:t>
+              <a:t>19</a:t>
             </a:fld>
             <a:endParaRPr lang="en-US"/>
           </a:p>
@@ -48410,7 +48617,324 @@
 </p:sld>
 </file>
 
-<file path=ppt/slides/slide19.xml><?xml version="1.0" encoding="utf-8"?>
+<file path=ppt/slides/slide2.xml><?xml version="1.0" encoding="utf-8"?>
+<p:sld xmlns:a="http://schemas.openxmlformats.org/drawingml/2006/main" xmlns:r="http://schemas.openxmlformats.org/officeDocument/2006/relationships" xmlns:p="http://schemas.openxmlformats.org/presentationml/2006/main">
+  <p:cSld>
+    <p:spTree>
+      <p:nvGrpSpPr>
+        <p:cNvPr id="1" name="">
+          <a:extLst>
+            <a:ext uri="{FF2B5EF4-FFF2-40B4-BE49-F238E27FC236}">
+              <a16:creationId xmlns:a16="http://schemas.microsoft.com/office/drawing/2014/main" id="{BA0730DC-F6C8-22C9-2A12-713C4E1E458B}"/>
+            </a:ext>
+          </a:extLst>
+        </p:cNvPr>
+        <p:cNvGrpSpPr/>
+        <p:nvPr/>
+      </p:nvGrpSpPr>
+      <p:grpSpPr>
+        <a:xfrm>
+          <a:off x="0" y="0"/>
+          <a:ext cx="0" cy="0"/>
+          <a:chOff x="0" y="0"/>
+          <a:chExt cx="0" cy="0"/>
+        </a:xfrm>
+      </p:grpSpPr>
+      <p:sp>
+        <p:nvSpPr>
+          <p:cNvPr id="2" name="Title 1">
+            <a:extLst>
+              <a:ext uri="{FF2B5EF4-FFF2-40B4-BE49-F238E27FC236}">
+                <a16:creationId xmlns:a16="http://schemas.microsoft.com/office/drawing/2014/main" id="{44193AAA-D656-4F94-34E8-AB59565878B7}"/>
+              </a:ext>
+            </a:extLst>
+          </p:cNvPr>
+          <p:cNvSpPr>
+            <a:spLocks noGrp="1"/>
+          </p:cNvSpPr>
+          <p:nvPr>
+            <p:ph type="title"/>
+          </p:nvPr>
+        </p:nvSpPr>
+        <p:spPr/>
+        <p:txBody>
+          <a:bodyPr/>
+          <a:lstStyle/>
+          <a:p>
+            <a:br>
+              <a:rPr lang="en-US" dirty="0"/>
+            </a:br>
+            <a:r>
+              <a:rPr lang="en-US" dirty="0"/>
+              <a:t>Before we start….</a:t>
+            </a:r>
+          </a:p>
+        </p:txBody>
+      </p:sp>
+      <p:sp>
+        <p:nvSpPr>
+          <p:cNvPr id="5" name="TextBox 4">
+            <a:extLst>
+              <a:ext uri="{FF2B5EF4-FFF2-40B4-BE49-F238E27FC236}">
+                <a16:creationId xmlns:a16="http://schemas.microsoft.com/office/drawing/2014/main" id="{8B514417-23DA-C546-6700-FBE2B4651B4A}"/>
+              </a:ext>
+            </a:extLst>
+          </p:cNvPr>
+          <p:cNvSpPr txBox="1"/>
+          <p:nvPr/>
+        </p:nvSpPr>
+        <p:spPr>
+          <a:xfrm>
+            <a:off x="1170878" y="1091086"/>
+            <a:ext cx="6477000" cy="3170099"/>
+          </a:xfrm>
+          <a:prstGeom prst="rect">
+            <a:avLst/>
+          </a:prstGeom>
+          <a:noFill/>
+        </p:spPr>
+        <p:txBody>
+          <a:bodyPr wrap="square">
+            <a:spAutoFit/>
+          </a:bodyPr>
+          <a:lstStyle/>
+          <a:p>
+            <a:pPr marL="342900" indent="-342900">
+              <a:buFont typeface="Arial" panose="020B0604020202020204" pitchFamily="34" charset="0"/>
+              <a:buChar char="•"/>
+            </a:pPr>
+            <a:r>
+              <a:rPr lang="en-US" sz="2000" dirty="0"/>
+              <a:t>Change your seats and take 5 minutes to get to know your new neighbors.  Sit by people you do not know!</a:t>
+            </a:r>
+          </a:p>
+          <a:p>
+            <a:pPr marL="342900" indent="-342900">
+              <a:buFont typeface="Arial" panose="020B0604020202020204" pitchFamily="34" charset="0"/>
+              <a:buChar char="•"/>
+            </a:pPr>
+            <a:endParaRPr lang="en-US" sz="2000" dirty="0"/>
+          </a:p>
+          <a:p>
+            <a:pPr marL="342900" indent="-342900">
+              <a:buFont typeface="Arial" panose="020B0604020202020204" pitchFamily="34" charset="0"/>
+              <a:buChar char="•"/>
+            </a:pPr>
+            <a:r>
+              <a:rPr lang="en-US" sz="2000" dirty="0"/>
+              <a:t>Let’s run through our git sequence so you can get my changes, and then create a Lesson3 notes for yourself…</a:t>
+            </a:r>
+          </a:p>
+          <a:p>
+            <a:pPr marL="342900" indent="-342900">
+              <a:buFont typeface="Arial" panose="020B0604020202020204" pitchFamily="34" charset="0"/>
+              <a:buChar char="•"/>
+            </a:pPr>
+            <a:endParaRPr lang="en-US" sz="2000" dirty="0"/>
+          </a:p>
+          <a:p>
+            <a:pPr marL="342900" indent="-342900">
+              <a:buFont typeface="Arial" panose="020B0604020202020204" pitchFamily="34" charset="0"/>
+              <a:buChar char="•"/>
+            </a:pPr>
+            <a:r>
+              <a:rPr lang="en-US" sz="2000" dirty="0"/>
+              <a:t>But what if you want to create your own repository…?</a:t>
+            </a:r>
+          </a:p>
+        </p:txBody>
+      </p:sp>
+    </p:spTree>
+    <p:extLst>
+      <p:ext uri="{BB962C8B-B14F-4D97-AF65-F5344CB8AC3E}">
+        <p14:creationId xmlns:p14="http://schemas.microsoft.com/office/powerpoint/2010/main" val="2603382457"/>
+      </p:ext>
+    </p:extLst>
+  </p:cSld>
+  <p:clrMapOvr>
+    <a:masterClrMapping/>
+  </p:clrMapOvr>
+  <p:timing>
+    <p:tnLst>
+      <p:par>
+        <p:cTn id="1" dur="indefinite" restart="never" nodeType="tmRoot">
+          <p:childTnLst>
+            <p:seq concurrent="1" nextAc="seek">
+              <p:cTn id="2" dur="indefinite" nodeType="mainSeq">
+                <p:childTnLst>
+                  <p:par>
+                    <p:cTn id="3" fill="hold">
+                      <p:stCondLst>
+                        <p:cond delay="indefinite"/>
+                      </p:stCondLst>
+                      <p:childTnLst>
+                        <p:par>
+                          <p:cTn id="4" fill="hold">
+                            <p:stCondLst>
+                              <p:cond delay="0"/>
+                            </p:stCondLst>
+                            <p:childTnLst>
+                              <p:par>
+                                <p:cTn id="5" presetID="1" presetClass="entr" presetSubtype="0" fill="hold" nodeType="clickEffect">
+                                  <p:stCondLst>
+                                    <p:cond delay="0"/>
+                                  </p:stCondLst>
+                                  <p:childTnLst>
+                                    <p:set>
+                                      <p:cBhvr>
+                                        <p:cTn id="6" dur="1" fill="hold">
+                                          <p:stCondLst>
+                                            <p:cond delay="0"/>
+                                          </p:stCondLst>
+                                        </p:cTn>
+                                        <p:tgtEl>
+                                          <p:spTgt spid="5">
+                                            <p:txEl>
+                                              <p:pRg st="0" end="0"/>
+                                            </p:txEl>
+                                          </p:spTgt>
+                                        </p:tgtEl>
+                                        <p:attrNameLst>
+                                          <p:attrName>style.visibility</p:attrName>
+                                        </p:attrNameLst>
+                                      </p:cBhvr>
+                                      <p:to>
+                                        <p:strVal val="visible"/>
+                                      </p:to>
+                                    </p:set>
+                                  </p:childTnLst>
+                                </p:cTn>
+                              </p:par>
+                            </p:childTnLst>
+                          </p:cTn>
+                        </p:par>
+                      </p:childTnLst>
+                    </p:cTn>
+                  </p:par>
+                  <p:par>
+                    <p:cTn id="7" fill="hold">
+                      <p:stCondLst>
+                        <p:cond delay="indefinite"/>
+                      </p:stCondLst>
+                      <p:childTnLst>
+                        <p:par>
+                          <p:cTn id="8" fill="hold">
+                            <p:stCondLst>
+                              <p:cond delay="0"/>
+                            </p:stCondLst>
+                            <p:childTnLst>
+                              <p:par>
+                                <p:cTn id="9" presetID="1" presetClass="entr" presetSubtype="0" fill="hold" nodeType="clickEffect">
+                                  <p:stCondLst>
+                                    <p:cond delay="0"/>
+                                  </p:stCondLst>
+                                  <p:childTnLst>
+                                    <p:set>
+                                      <p:cBhvr>
+                                        <p:cTn id="10" dur="1" fill="hold">
+                                          <p:stCondLst>
+                                            <p:cond delay="0"/>
+                                          </p:stCondLst>
+                                        </p:cTn>
+                                        <p:tgtEl>
+                                          <p:spTgt spid="5">
+                                            <p:txEl>
+                                              <p:pRg st="2" end="2"/>
+                                            </p:txEl>
+                                          </p:spTgt>
+                                        </p:tgtEl>
+                                        <p:attrNameLst>
+                                          <p:attrName>style.visibility</p:attrName>
+                                        </p:attrNameLst>
+                                      </p:cBhvr>
+                                      <p:to>
+                                        <p:strVal val="visible"/>
+                                      </p:to>
+                                    </p:set>
+                                  </p:childTnLst>
+                                </p:cTn>
+                              </p:par>
+                            </p:childTnLst>
+                          </p:cTn>
+                        </p:par>
+                      </p:childTnLst>
+                    </p:cTn>
+                  </p:par>
+                  <p:par>
+                    <p:cTn id="11" fill="hold">
+                      <p:stCondLst>
+                        <p:cond delay="indefinite"/>
+                      </p:stCondLst>
+                      <p:childTnLst>
+                        <p:par>
+                          <p:cTn id="12" fill="hold">
+                            <p:stCondLst>
+                              <p:cond delay="0"/>
+                            </p:stCondLst>
+                            <p:childTnLst>
+                              <p:par>
+                                <p:cTn id="13" presetID="1" presetClass="entr" presetSubtype="0" fill="hold" nodeType="clickEffect">
+                                  <p:stCondLst>
+                                    <p:cond delay="0"/>
+                                  </p:stCondLst>
+                                  <p:childTnLst>
+                                    <p:set>
+                                      <p:cBhvr>
+                                        <p:cTn id="14" dur="1" fill="hold">
+                                          <p:stCondLst>
+                                            <p:cond delay="0"/>
+                                          </p:stCondLst>
+                                        </p:cTn>
+                                        <p:tgtEl>
+                                          <p:spTgt spid="5">
+                                            <p:txEl>
+                                              <p:pRg st="4" end="4"/>
+                                            </p:txEl>
+                                          </p:spTgt>
+                                        </p:tgtEl>
+                                        <p:attrNameLst>
+                                          <p:attrName>style.visibility</p:attrName>
+                                        </p:attrNameLst>
+                                      </p:cBhvr>
+                                      <p:to>
+                                        <p:strVal val="visible"/>
+                                      </p:to>
+                                    </p:set>
+                                  </p:childTnLst>
+                                </p:cTn>
+                              </p:par>
+                            </p:childTnLst>
+                          </p:cTn>
+                        </p:par>
+                      </p:childTnLst>
+                    </p:cTn>
+                  </p:par>
+                </p:childTnLst>
+              </p:cTn>
+              <p:prevCondLst>
+                <p:cond evt="onPrev" delay="0">
+                  <p:tgtEl>
+                    <p:sldTgt/>
+                  </p:tgtEl>
+                </p:cond>
+              </p:prevCondLst>
+              <p:nextCondLst>
+                <p:cond evt="onNext" delay="0">
+                  <p:tgtEl>
+                    <p:sldTgt/>
+                  </p:tgtEl>
+                </p:cond>
+              </p:nextCondLst>
+            </p:seq>
+          </p:childTnLst>
+        </p:cTn>
+      </p:par>
+    </p:tnLst>
+  </p:timing>
+</p:sld>
+</file>
+
+<file path=ppt/slides/slide20.xml><?xml version="1.0" encoding="utf-8"?>
 <p:sld xmlns:a="http://schemas.openxmlformats.org/drawingml/2006/main" xmlns:r="http://schemas.openxmlformats.org/officeDocument/2006/relationships" xmlns:p="http://schemas.openxmlformats.org/presentationml/2006/main">
   <p:cSld>
     <p:spTree>
@@ -48451,7 +48975,7 @@
             <a:fld id="{71B8893A-F325-44A6-8EFB-883C20332CFE}" type="slidenum">
               <a:rPr lang="en-US" smtClean="0"/>
               <a:pPr/>
-              <a:t>19</a:t>
+              <a:t>20</a:t>
             </a:fld>
             <a:endParaRPr lang="en-US"/>
           </a:p>
@@ -48538,242 +49062,7 @@
 </p:sld>
 </file>
 
-<file path=ppt/slides/slide2.xml><?xml version="1.0" encoding="utf-8"?>
-<p:sld xmlns:a="http://schemas.openxmlformats.org/drawingml/2006/main" xmlns:r="http://schemas.openxmlformats.org/officeDocument/2006/relationships" xmlns:p="http://schemas.openxmlformats.org/presentationml/2006/main">
-  <p:cSld>
-    <p:spTree>
-      <p:nvGrpSpPr>
-        <p:cNvPr id="1" name="">
-          <a:extLst>
-            <a:ext uri="{FF2B5EF4-FFF2-40B4-BE49-F238E27FC236}">
-              <a16:creationId xmlns:a16="http://schemas.microsoft.com/office/drawing/2014/main" id="{5B19D20E-BD9A-847F-707A-41F7A86C8D39}"/>
-            </a:ext>
-          </a:extLst>
-        </p:cNvPr>
-        <p:cNvGrpSpPr/>
-        <p:nvPr/>
-      </p:nvGrpSpPr>
-      <p:grpSpPr>
-        <a:xfrm>
-          <a:off x="0" y="0"/>
-          <a:ext cx="0" cy="0"/>
-          <a:chOff x="0" y="0"/>
-          <a:chExt cx="0" cy="0"/>
-        </a:xfrm>
-      </p:grpSpPr>
-      <p:sp>
-        <p:nvSpPr>
-          <p:cNvPr id="2" name="Title 1">
-            <a:extLst>
-              <a:ext uri="{FF2B5EF4-FFF2-40B4-BE49-F238E27FC236}">
-                <a16:creationId xmlns:a16="http://schemas.microsoft.com/office/drawing/2014/main" id="{DC869BD9-8066-F6DB-BC59-621195265012}"/>
-              </a:ext>
-            </a:extLst>
-          </p:cNvPr>
-          <p:cNvSpPr>
-            <a:spLocks noGrp="1"/>
-          </p:cNvSpPr>
-          <p:nvPr>
-            <p:ph type="title"/>
-          </p:nvPr>
-        </p:nvSpPr>
-        <p:spPr/>
-        <p:txBody>
-          <a:bodyPr/>
-          <a:lstStyle/>
-          <a:p>
-            <a:br>
-              <a:rPr lang="en-US" dirty="0"/>
-            </a:br>
-            <a:r>
-              <a:rPr lang="en-US" dirty="0"/>
-              <a:t>Motivation</a:t>
-            </a:r>
-          </a:p>
-        </p:txBody>
-      </p:sp>
-      <p:pic>
-        <p:nvPicPr>
-          <p:cNvPr id="3" name="Online Media 2" title="Parkour PARKOUR - The Office US">
-            <a:hlinkClick r:id="" action="ppaction://media"/>
-            <a:extLst>
-              <a:ext uri="{FF2B5EF4-FFF2-40B4-BE49-F238E27FC236}">
-                <a16:creationId xmlns:a16="http://schemas.microsoft.com/office/drawing/2014/main" id="{FA0752D9-62DB-4F2A-4CBE-93C77F0E189F}"/>
-              </a:ext>
-            </a:extLst>
-          </p:cNvPr>
-          <p:cNvPicPr>
-            <a:picLocks noRot="1" noChangeAspect="1"/>
-          </p:cNvPicPr>
-          <p:nvPr>
-            <a:videoFile r:link="rId1"/>
-          </p:nvPr>
-        </p:nvPicPr>
-        <p:blipFill>
-          <a:blip r:embed="rId4"/>
-          <a:stretch>
-            <a:fillRect/>
-          </a:stretch>
-        </p:blipFill>
-        <p:spPr>
-          <a:xfrm>
-            <a:off x="981308" y="754072"/>
-            <a:ext cx="7019500" cy="3965681"/>
-          </a:xfrm>
-          <a:prstGeom prst="rect">
-            <a:avLst/>
-          </a:prstGeom>
-        </p:spPr>
-      </p:pic>
-    </p:spTree>
-    <p:extLst>
-      <p:ext uri="{BB962C8B-B14F-4D97-AF65-F5344CB8AC3E}">
-        <p14:creationId xmlns:p14="http://schemas.microsoft.com/office/powerpoint/2010/main" val="2254684427"/>
-      </p:ext>
-    </p:extLst>
-  </p:cSld>
-  <p:clrMapOvr>
-    <a:masterClrMapping/>
-  </p:clrMapOvr>
-  <p:timing>
-    <p:tnLst>
-      <p:par>
-        <p:cTn id="1" dur="indefinite" restart="never" nodeType="tmRoot">
-          <p:childTnLst>
-            <p:seq concurrent="1" nextAc="seek">
-              <p:cTn id="2" dur="indefinite" nodeType="mainSeq">
-                <p:childTnLst>
-                  <p:par>
-                    <p:cTn id="3" fill="hold">
-                      <p:stCondLst>
-                        <p:cond delay="indefinite"/>
-                      </p:stCondLst>
-                      <p:childTnLst>
-                        <p:par>
-                          <p:cTn id="4" fill="hold">
-                            <p:stCondLst>
-                              <p:cond delay="0"/>
-                            </p:stCondLst>
-                            <p:childTnLst>
-                              <p:par>
-                                <p:cTn id="5" presetID="1" presetClass="mediacall" presetSubtype="0" fill="hold" nodeType="clickEffect">
-                                  <p:stCondLst>
-                                    <p:cond delay="0"/>
-                                  </p:stCondLst>
-                                  <p:childTnLst>
-                                    <p:cmd type="call" cmd="playFrom(0.0)">
-                                      <p:cBhvr>
-                                        <p:cTn id="6" dur="1" fill="hold"/>
-                                        <p:tgtEl>
-                                          <p:spTgt spid="3"/>
-                                        </p:tgtEl>
-                                      </p:cBhvr>
-                                    </p:cmd>
-                                  </p:childTnLst>
-                                </p:cTn>
-                              </p:par>
-                            </p:childTnLst>
-                          </p:cTn>
-                        </p:par>
-                      </p:childTnLst>
-                    </p:cTn>
-                  </p:par>
-                </p:childTnLst>
-              </p:cTn>
-              <p:prevCondLst>
-                <p:cond evt="onPrev" delay="0">
-                  <p:tgtEl>
-                    <p:sldTgt/>
-                  </p:tgtEl>
-                </p:cond>
-              </p:prevCondLst>
-              <p:nextCondLst>
-                <p:cond evt="onNext" delay="0">
-                  <p:tgtEl>
-                    <p:sldTgt/>
-                  </p:tgtEl>
-                </p:cond>
-              </p:nextCondLst>
-            </p:seq>
-            <p:video>
-              <p:cMediaNode vol="80000">
-                <p:cTn id="7" fill="hold" display="0">
-                  <p:stCondLst>
-                    <p:cond delay="indefinite"/>
-                  </p:stCondLst>
-                </p:cTn>
-                <p:tgtEl>
-                  <p:spTgt spid="3"/>
-                </p:tgtEl>
-              </p:cMediaNode>
-            </p:video>
-            <p:seq concurrent="1" nextAc="seek">
-              <p:cTn id="8" restart="whenNotActive" fill="hold" evtFilter="cancelBubble" nodeType="interactiveSeq">
-                <p:stCondLst>
-                  <p:cond evt="onClick" delay="0">
-                    <p:tgtEl>
-                      <p:spTgt spid="3"/>
-                    </p:tgtEl>
-                  </p:cond>
-                </p:stCondLst>
-                <p:endSync evt="end" delay="0">
-                  <p:rtn val="all"/>
-                </p:endSync>
-                <p:childTnLst>
-                  <p:par>
-                    <p:cTn id="9" fill="hold">
-                      <p:stCondLst>
-                        <p:cond delay="0"/>
-                      </p:stCondLst>
-                      <p:childTnLst>
-                        <p:par>
-                          <p:cTn id="10" fill="hold">
-                            <p:stCondLst>
-                              <p:cond delay="0"/>
-                            </p:stCondLst>
-                            <p:childTnLst>
-                              <p:par>
-                                <p:cTn id="11" presetID="2" presetClass="mediacall" presetSubtype="0" fill="hold" nodeType="clickEffect">
-                                  <p:stCondLst>
-                                    <p:cond delay="0"/>
-                                  </p:stCondLst>
-                                  <p:childTnLst>
-                                    <p:cmd type="call" cmd="togglePause">
-                                      <p:cBhvr>
-                                        <p:cTn id="12" dur="1" fill="hold"/>
-                                        <p:tgtEl>
-                                          <p:spTgt spid="3"/>
-                                        </p:tgtEl>
-                                      </p:cBhvr>
-                                    </p:cmd>
-                                  </p:childTnLst>
-                                </p:cTn>
-                              </p:par>
-                            </p:childTnLst>
-                          </p:cTn>
-                        </p:par>
-                      </p:childTnLst>
-                    </p:cTn>
-                  </p:par>
-                </p:childTnLst>
-              </p:cTn>
-              <p:nextCondLst>
-                <p:cond evt="onClick" delay="0">
-                  <p:tgtEl>
-                    <p:spTgt spid="3"/>
-                  </p:tgtEl>
-                </p:cond>
-              </p:nextCondLst>
-            </p:seq>
-          </p:childTnLst>
-        </p:cTn>
-      </p:par>
-    </p:tnLst>
-  </p:timing>
-</p:sld>
-</file>
-
-<file path=ppt/slides/slide20.xml><?xml version="1.0" encoding="utf-8"?>
+<file path=ppt/slides/slide21.xml><?xml version="1.0" encoding="utf-8"?>
 <p:sld xmlns:a="http://schemas.openxmlformats.org/drawingml/2006/main" xmlns:r="http://schemas.openxmlformats.org/officeDocument/2006/relationships" xmlns:p="http://schemas.openxmlformats.org/presentationml/2006/main">
   <p:cSld>
     <p:spTree>
@@ -48842,7 +49131,7 @@
 </p:sld>
 </file>
 
-<file path=ppt/slides/slide21.xml><?xml version="1.0" encoding="utf-8"?>
+<file path=ppt/slides/slide22.xml><?xml version="1.0" encoding="utf-8"?>
 <p:sld xmlns:a="http://schemas.openxmlformats.org/drawingml/2006/main" xmlns:r="http://schemas.openxmlformats.org/officeDocument/2006/relationships" xmlns:p="http://schemas.openxmlformats.org/presentationml/2006/main">
   <p:cSld>
     <p:spTree>
@@ -50639,7 +50928,7 @@
 </p:sld>
 </file>
 
-<file path=ppt/slides/slide22.xml><?xml version="1.0" encoding="utf-8"?>
+<file path=ppt/slides/slide23.xml><?xml version="1.0" encoding="utf-8"?>
 <p:sld xmlns:a="http://schemas.openxmlformats.org/drawingml/2006/main" xmlns:r="http://schemas.openxmlformats.org/officeDocument/2006/relationships" xmlns:p="http://schemas.openxmlformats.org/presentationml/2006/main">
   <p:cSld>
     <p:spTree>
@@ -50740,7 +51029,7 @@
 </p:sld>
 </file>
 
-<file path=ppt/slides/slide23.xml><?xml version="1.0" encoding="utf-8"?>
+<file path=ppt/slides/slide24.xml><?xml version="1.0" encoding="utf-8"?>
 <p:sld xmlns:a="http://schemas.openxmlformats.org/drawingml/2006/main" xmlns:r="http://schemas.openxmlformats.org/officeDocument/2006/relationships" xmlns:p="http://schemas.openxmlformats.org/presentationml/2006/main">
   <p:cSld>
     <p:spTree>
@@ -50857,7 +51146,7 @@
 </p:sld>
 </file>
 
-<file path=ppt/slides/slide24.xml><?xml version="1.0" encoding="utf-8"?>
+<file path=ppt/slides/slide25.xml><?xml version="1.0" encoding="utf-8"?>
 <p:sld xmlns:a="http://schemas.openxmlformats.org/drawingml/2006/main" xmlns:r="http://schemas.openxmlformats.org/officeDocument/2006/relationships" xmlns:p="http://schemas.openxmlformats.org/presentationml/2006/main">
   <p:cSld>
     <p:spTree>
@@ -50956,7 +51245,7 @@
 </p:sld>
 </file>
 
-<file path=ppt/slides/slide25.xml><?xml version="1.0" encoding="utf-8"?>
+<file path=ppt/slides/slide26.xml><?xml version="1.0" encoding="utf-8"?>
 <p:sld xmlns:a="http://schemas.openxmlformats.org/drawingml/2006/main" xmlns:r="http://schemas.openxmlformats.org/officeDocument/2006/relationships" xmlns:p="http://schemas.openxmlformats.org/presentationml/2006/main">
   <p:cSld>
     <p:spTree>
@@ -51060,7 +51349,7 @@
 </p:sld>
 </file>
 
-<file path=ppt/slides/slide26.xml><?xml version="1.0" encoding="utf-8"?>
+<file path=ppt/slides/slide27.xml><?xml version="1.0" encoding="utf-8"?>
 <p:sld xmlns:a="http://schemas.openxmlformats.org/drawingml/2006/main" xmlns:r="http://schemas.openxmlformats.org/officeDocument/2006/relationships" xmlns:p="http://schemas.openxmlformats.org/presentationml/2006/main">
   <p:cSld>
     <p:spTree>
@@ -51156,7 +51445,7 @@
 </p:sld>
 </file>
 
-<file path=ppt/slides/slide27.xml><?xml version="1.0" encoding="utf-8"?>
+<file path=ppt/slides/slide28.xml><?xml version="1.0" encoding="utf-8"?>
 <p:sld xmlns:a="http://schemas.openxmlformats.org/drawingml/2006/main" xmlns:r="http://schemas.openxmlformats.org/officeDocument/2006/relationships" xmlns:p="http://schemas.openxmlformats.org/presentationml/2006/main">
   <p:cSld>
     <p:spTree>
@@ -51219,7 +51508,7 @@
 </p:sld>
 </file>
 
-<file path=ppt/slides/slide28.xml><?xml version="1.0" encoding="utf-8"?>
+<file path=ppt/slides/slide29.xml><?xml version="1.0" encoding="utf-8"?>
 <p:sld xmlns:a="http://schemas.openxmlformats.org/drawingml/2006/main" xmlns:r="http://schemas.openxmlformats.org/officeDocument/2006/relationships" xmlns:p="http://schemas.openxmlformats.org/presentationml/2006/main">
   <p:cSld>
     <p:spTree>
@@ -51279,6 +51568,241 @@
 </file>
 
 <file path=ppt/slides/slide3.xml><?xml version="1.0" encoding="utf-8"?>
+<p:sld xmlns:a="http://schemas.openxmlformats.org/drawingml/2006/main" xmlns:r="http://schemas.openxmlformats.org/officeDocument/2006/relationships" xmlns:p="http://schemas.openxmlformats.org/presentationml/2006/main">
+  <p:cSld>
+    <p:spTree>
+      <p:nvGrpSpPr>
+        <p:cNvPr id="1" name="">
+          <a:extLst>
+            <a:ext uri="{FF2B5EF4-FFF2-40B4-BE49-F238E27FC236}">
+              <a16:creationId xmlns:a16="http://schemas.microsoft.com/office/drawing/2014/main" id="{5B19D20E-BD9A-847F-707A-41F7A86C8D39}"/>
+            </a:ext>
+          </a:extLst>
+        </p:cNvPr>
+        <p:cNvGrpSpPr/>
+        <p:nvPr/>
+      </p:nvGrpSpPr>
+      <p:grpSpPr>
+        <a:xfrm>
+          <a:off x="0" y="0"/>
+          <a:ext cx="0" cy="0"/>
+          <a:chOff x="0" y="0"/>
+          <a:chExt cx="0" cy="0"/>
+        </a:xfrm>
+      </p:grpSpPr>
+      <p:sp>
+        <p:nvSpPr>
+          <p:cNvPr id="2" name="Title 1">
+            <a:extLst>
+              <a:ext uri="{FF2B5EF4-FFF2-40B4-BE49-F238E27FC236}">
+                <a16:creationId xmlns:a16="http://schemas.microsoft.com/office/drawing/2014/main" id="{DC869BD9-8066-F6DB-BC59-621195265012}"/>
+              </a:ext>
+            </a:extLst>
+          </p:cNvPr>
+          <p:cNvSpPr>
+            <a:spLocks noGrp="1"/>
+          </p:cNvSpPr>
+          <p:nvPr>
+            <p:ph type="title"/>
+          </p:nvPr>
+        </p:nvSpPr>
+        <p:spPr/>
+        <p:txBody>
+          <a:bodyPr/>
+          <a:lstStyle/>
+          <a:p>
+            <a:br>
+              <a:rPr lang="en-US" dirty="0"/>
+            </a:br>
+            <a:r>
+              <a:rPr lang="en-US" dirty="0"/>
+              <a:t>Motivation</a:t>
+            </a:r>
+          </a:p>
+        </p:txBody>
+      </p:sp>
+      <p:pic>
+        <p:nvPicPr>
+          <p:cNvPr id="3" name="Online Media 2" title="Parkour PARKOUR - The Office US">
+            <a:hlinkClick r:id="" action="ppaction://media"/>
+            <a:extLst>
+              <a:ext uri="{FF2B5EF4-FFF2-40B4-BE49-F238E27FC236}">
+                <a16:creationId xmlns:a16="http://schemas.microsoft.com/office/drawing/2014/main" id="{FA0752D9-62DB-4F2A-4CBE-93C77F0E189F}"/>
+              </a:ext>
+            </a:extLst>
+          </p:cNvPr>
+          <p:cNvPicPr>
+            <a:picLocks noRot="1" noChangeAspect="1"/>
+          </p:cNvPicPr>
+          <p:nvPr>
+            <a:videoFile r:link="rId1"/>
+          </p:nvPr>
+        </p:nvPicPr>
+        <p:blipFill>
+          <a:blip r:embed="rId4"/>
+          <a:stretch>
+            <a:fillRect/>
+          </a:stretch>
+        </p:blipFill>
+        <p:spPr>
+          <a:xfrm>
+            <a:off x="981308" y="754072"/>
+            <a:ext cx="7019500" cy="3965681"/>
+          </a:xfrm>
+          <a:prstGeom prst="rect">
+            <a:avLst/>
+          </a:prstGeom>
+        </p:spPr>
+      </p:pic>
+    </p:spTree>
+    <p:extLst>
+      <p:ext uri="{BB962C8B-B14F-4D97-AF65-F5344CB8AC3E}">
+        <p14:creationId xmlns:p14="http://schemas.microsoft.com/office/powerpoint/2010/main" val="2254684427"/>
+      </p:ext>
+    </p:extLst>
+  </p:cSld>
+  <p:clrMapOvr>
+    <a:masterClrMapping/>
+  </p:clrMapOvr>
+  <p:timing>
+    <p:tnLst>
+      <p:par>
+        <p:cTn id="1" dur="indefinite" restart="never" nodeType="tmRoot">
+          <p:childTnLst>
+            <p:seq concurrent="1" nextAc="seek">
+              <p:cTn id="2" dur="indefinite" nodeType="mainSeq">
+                <p:childTnLst>
+                  <p:par>
+                    <p:cTn id="3" fill="hold">
+                      <p:stCondLst>
+                        <p:cond delay="indefinite"/>
+                      </p:stCondLst>
+                      <p:childTnLst>
+                        <p:par>
+                          <p:cTn id="4" fill="hold">
+                            <p:stCondLst>
+                              <p:cond delay="0"/>
+                            </p:stCondLst>
+                            <p:childTnLst>
+                              <p:par>
+                                <p:cTn id="5" presetID="1" presetClass="mediacall" presetSubtype="0" fill="hold" nodeType="clickEffect">
+                                  <p:stCondLst>
+                                    <p:cond delay="0"/>
+                                  </p:stCondLst>
+                                  <p:childTnLst>
+                                    <p:cmd type="call" cmd="playFrom(0.0)">
+                                      <p:cBhvr>
+                                        <p:cTn id="6" dur="1" fill="hold"/>
+                                        <p:tgtEl>
+                                          <p:spTgt spid="3"/>
+                                        </p:tgtEl>
+                                      </p:cBhvr>
+                                    </p:cmd>
+                                  </p:childTnLst>
+                                </p:cTn>
+                              </p:par>
+                            </p:childTnLst>
+                          </p:cTn>
+                        </p:par>
+                      </p:childTnLst>
+                    </p:cTn>
+                  </p:par>
+                </p:childTnLst>
+              </p:cTn>
+              <p:prevCondLst>
+                <p:cond evt="onPrev" delay="0">
+                  <p:tgtEl>
+                    <p:sldTgt/>
+                  </p:tgtEl>
+                </p:cond>
+              </p:prevCondLst>
+              <p:nextCondLst>
+                <p:cond evt="onNext" delay="0">
+                  <p:tgtEl>
+                    <p:sldTgt/>
+                  </p:tgtEl>
+                </p:cond>
+              </p:nextCondLst>
+            </p:seq>
+            <p:video>
+              <p:cMediaNode vol="80000">
+                <p:cTn id="7" fill="hold" display="0">
+                  <p:stCondLst>
+                    <p:cond delay="indefinite"/>
+                  </p:stCondLst>
+                </p:cTn>
+                <p:tgtEl>
+                  <p:spTgt spid="3"/>
+                </p:tgtEl>
+              </p:cMediaNode>
+            </p:video>
+            <p:seq concurrent="1" nextAc="seek">
+              <p:cTn id="8" restart="whenNotActive" fill="hold" evtFilter="cancelBubble" nodeType="interactiveSeq">
+                <p:stCondLst>
+                  <p:cond evt="onClick" delay="0">
+                    <p:tgtEl>
+                      <p:spTgt spid="3"/>
+                    </p:tgtEl>
+                  </p:cond>
+                </p:stCondLst>
+                <p:endSync evt="end" delay="0">
+                  <p:rtn val="all"/>
+                </p:endSync>
+                <p:childTnLst>
+                  <p:par>
+                    <p:cTn id="9" fill="hold">
+                      <p:stCondLst>
+                        <p:cond delay="0"/>
+                      </p:stCondLst>
+                      <p:childTnLst>
+                        <p:par>
+                          <p:cTn id="10" fill="hold">
+                            <p:stCondLst>
+                              <p:cond delay="0"/>
+                            </p:stCondLst>
+                            <p:childTnLst>
+                              <p:par>
+                                <p:cTn id="11" presetID="2" presetClass="mediacall" presetSubtype="0" fill="hold" nodeType="clickEffect">
+                                  <p:stCondLst>
+                                    <p:cond delay="0"/>
+                                  </p:stCondLst>
+                                  <p:childTnLst>
+                                    <p:cmd type="call" cmd="togglePause">
+                                      <p:cBhvr>
+                                        <p:cTn id="12" dur="1" fill="hold"/>
+                                        <p:tgtEl>
+                                          <p:spTgt spid="3"/>
+                                        </p:tgtEl>
+                                      </p:cBhvr>
+                                    </p:cmd>
+                                  </p:childTnLst>
+                                </p:cTn>
+                              </p:par>
+                            </p:childTnLst>
+                          </p:cTn>
+                        </p:par>
+                      </p:childTnLst>
+                    </p:cTn>
+                  </p:par>
+                </p:childTnLst>
+              </p:cTn>
+              <p:nextCondLst>
+                <p:cond evt="onClick" delay="0">
+                  <p:tgtEl>
+                    <p:spTgt spid="3"/>
+                  </p:tgtEl>
+                </p:cond>
+              </p:nextCondLst>
+            </p:seq>
+          </p:childTnLst>
+        </p:cTn>
+      </p:par>
+    </p:tnLst>
+  </p:timing>
+</p:sld>
+</file>
+
+<file path=ppt/slides/slide4.xml><?xml version="1.0" encoding="utf-8"?>
 <p:sld xmlns:a="http://schemas.openxmlformats.org/drawingml/2006/main" xmlns:r="http://schemas.openxmlformats.org/officeDocument/2006/relationships" xmlns:p="http://schemas.openxmlformats.org/presentationml/2006/main">
   <p:cSld>
     <p:spTree>
@@ -51596,7 +52120,7 @@
 </p:sld>
 </file>
 
-<file path=ppt/slides/slide4.xml><?xml version="1.0" encoding="utf-8"?>
+<file path=ppt/slides/slide5.xml><?xml version="1.0" encoding="utf-8"?>
 <p:sld xmlns:a="http://schemas.openxmlformats.org/drawingml/2006/main" xmlns:r="http://schemas.openxmlformats.org/officeDocument/2006/relationships" xmlns:p="http://schemas.openxmlformats.org/presentationml/2006/main">
   <p:cSld>
     <p:spTree>
@@ -51751,7 +52275,7 @@
 </p:sld>
 </file>
 
-<file path=ppt/slides/slide5.xml><?xml version="1.0" encoding="utf-8"?>
+<file path=ppt/slides/slide6.xml><?xml version="1.0" encoding="utf-8"?>
 <p:sld xmlns:a="http://schemas.openxmlformats.org/drawingml/2006/main" xmlns:r="http://schemas.openxmlformats.org/officeDocument/2006/relationships" xmlns:p="http://schemas.openxmlformats.org/presentationml/2006/main">
   <p:cSld>
     <p:spTree>
@@ -51820,7 +52344,7 @@
 </p:sld>
 </file>
 
-<file path=ppt/slides/slide6.xml><?xml version="1.0" encoding="utf-8"?>
+<file path=ppt/slides/slide7.xml><?xml version="1.0" encoding="utf-8"?>
 <p:sld xmlns:a="http://schemas.openxmlformats.org/drawingml/2006/main" xmlns:r="http://schemas.openxmlformats.org/officeDocument/2006/relationships" xmlns:p="http://schemas.openxmlformats.org/presentationml/2006/main">
   <p:cSld>
     <p:spTree>
@@ -51971,7 +52495,7 @@
 </p:sld>
 </file>
 
-<file path=ppt/slides/slide7.xml><?xml version="1.0" encoding="utf-8"?>
+<file path=ppt/slides/slide8.xml><?xml version="1.0" encoding="utf-8"?>
 <p:sld xmlns:a="http://schemas.openxmlformats.org/drawingml/2006/main" xmlns:r="http://schemas.openxmlformats.org/officeDocument/2006/relationships" xmlns:p="http://schemas.openxmlformats.org/presentationml/2006/main">
   <p:cSld>
     <p:spTree>
@@ -52169,7 +52693,7 @@
 </p:sld>
 </file>
 
-<file path=ppt/slides/slide8.xml><?xml version="1.0" encoding="utf-8"?>
+<file path=ppt/slides/slide9.xml><?xml version="1.0" encoding="utf-8"?>
 <p:sld xmlns:a="http://schemas.openxmlformats.org/drawingml/2006/main" xmlns:r="http://schemas.openxmlformats.org/officeDocument/2006/relationships" xmlns:p="http://schemas.openxmlformats.org/presentationml/2006/main">
   <p:cSld>
     <p:spTree>
@@ -52229,99 +52753,6 @@
     <p:extLst>
       <p:ext uri="{BB962C8B-B14F-4D97-AF65-F5344CB8AC3E}">
         <p14:creationId xmlns:p14="http://schemas.microsoft.com/office/powerpoint/2010/main" val="299971120"/>
-      </p:ext>
-    </p:extLst>
-  </p:cSld>
-  <p:clrMapOvr>
-    <a:masterClrMapping/>
-  </p:clrMapOvr>
-</p:sld>
-</file>
-
-<file path=ppt/slides/slide9.xml><?xml version="1.0" encoding="utf-8"?>
-<p:sld xmlns:a="http://schemas.openxmlformats.org/drawingml/2006/main" xmlns:r="http://schemas.openxmlformats.org/officeDocument/2006/relationships" xmlns:p="http://schemas.openxmlformats.org/presentationml/2006/main">
-  <p:cSld>
-    <p:spTree>
-      <p:nvGrpSpPr>
-        <p:cNvPr id="1" name=""/>
-        <p:cNvGrpSpPr/>
-        <p:nvPr/>
-      </p:nvGrpSpPr>
-      <p:grpSpPr>
-        <a:xfrm>
-          <a:off x="0" y="0"/>
-          <a:ext cx="0" cy="0"/>
-          <a:chOff x="0" y="0"/>
-          <a:chExt cx="0" cy="0"/>
-        </a:xfrm>
-      </p:grpSpPr>
-      <p:sp>
-        <p:nvSpPr>
-          <p:cNvPr id="4" name="Slide Number Placeholder 3">
-            <a:extLst>
-              <a:ext uri="{FF2B5EF4-FFF2-40B4-BE49-F238E27FC236}">
-                <a16:creationId xmlns:a16="http://schemas.microsoft.com/office/drawing/2014/main" id="{D0F0E6DB-EE9E-45C5-B784-49ED7052A2EB}"/>
-              </a:ext>
-            </a:extLst>
-          </p:cNvPr>
-          <p:cNvSpPr>
-            <a:spLocks noGrp="1"/>
-          </p:cNvSpPr>
-          <p:nvPr>
-            <p:ph type="sldNum" sz="quarter" idx="4"/>
-          </p:nvPr>
-        </p:nvSpPr>
-        <p:spPr/>
-        <p:txBody>
-          <a:bodyPr/>
-          <a:lstStyle/>
-          <a:p>
-            <a:fld id="{71B8893A-F325-44A6-8EFB-883C20332CFE}" type="slidenum">
-              <a:rPr lang="en-US" smtClean="0"/>
-              <a:pPr/>
-              <a:t>9</a:t>
-            </a:fld>
-            <a:endParaRPr lang="en-US"/>
-          </a:p>
-        </p:txBody>
-      </p:sp>
-      <p:sp>
-        <p:nvSpPr>
-          <p:cNvPr id="3" name="Title 2">
-            <a:extLst>
-              <a:ext uri="{FF2B5EF4-FFF2-40B4-BE49-F238E27FC236}">
-                <a16:creationId xmlns:a16="http://schemas.microsoft.com/office/drawing/2014/main" id="{DA67ABD9-8A31-4CB9-94E1-A0DA84E71640}"/>
-              </a:ext>
-            </a:extLst>
-          </p:cNvPr>
-          <p:cNvSpPr>
-            <a:spLocks noGrp="1"/>
-          </p:cNvSpPr>
-          <p:nvPr>
-            <p:ph type="title"/>
-          </p:nvPr>
-        </p:nvSpPr>
-        <p:spPr>
-          <a:xfrm>
-            <a:off x="381000" y="1857375"/>
-            <a:ext cx="8382000" cy="857250"/>
-          </a:xfrm>
-        </p:spPr>
-        <p:txBody>
-          <a:bodyPr/>
-          <a:lstStyle/>
-          <a:p>
-            <a:r>
-              <a:rPr lang="en-US" dirty="0"/>
-              <a:t>What are some built-in Python functions that we have learned about?</a:t>
-            </a:r>
-          </a:p>
-        </p:txBody>
-      </p:sp>
-    </p:spTree>
-    <p:extLst>
-      <p:ext uri="{BB962C8B-B14F-4D97-AF65-F5344CB8AC3E}">
-        <p14:creationId xmlns:p14="http://schemas.microsoft.com/office/powerpoint/2010/main" val="1359797099"/>
       </p:ext>
     </p:extLst>
   </p:cSld>

</xml_diff>